<commit_message>
fix(g8-e): contain clean-checkout runtime incident
</commit_message>
<xml_diff>
--- a/deliverables/review-1/semantic-communication-first-review.pptx
+++ b/deliverables/review-1/semantic-communication-first-review.pptx
@@ -5,20 +5,20 @@
     <p:sldMasterId id="2147483648" r:id="rId1"/>
   </p:sldMasterIdLst>
   <p:sldIdLst>
-    <p:sldId id="256" r:id="rId7"/>
-    <p:sldId id="257" r:id="rId8"/>
-    <p:sldId id="258" r:id="rId9"/>
-    <p:sldId id="259" r:id="rId10"/>
-    <p:sldId id="260" r:id="rId11"/>
-    <p:sldId id="261" r:id="rId12"/>
-    <p:sldId id="262" r:id="rId13"/>
-    <p:sldId id="263" r:id="rId14"/>
-    <p:sldId id="264" r:id="rId15"/>
-    <p:sldId id="265" r:id="rId16"/>
-    <p:sldId id="266" r:id="rId17"/>
-    <p:sldId id="267" r:id="rId18"/>
+    <p:sldId id="256" r:id="rId2"/>
+    <p:sldId id="257" r:id="rId3"/>
+    <p:sldId id="258" r:id="rId4"/>
+    <p:sldId id="259" r:id="rId5"/>
+    <p:sldId id="260" r:id="rId6"/>
+    <p:sldId id="261" r:id="rId7"/>
+    <p:sldId id="262" r:id="rId8"/>
+    <p:sldId id="263" r:id="rId9"/>
+    <p:sldId id="264" r:id="rId10"/>
+    <p:sldId id="265" r:id="rId11"/>
+    <p:sldId id="266" r:id="rId12"/>
+    <p:sldId id="267" r:id="rId13"/>
   </p:sldIdLst>
-  <p:sldSz cx="12191695" cy="6858000" type="screen4x3"/>
+  <p:sldSz cx="12192000" cy="6858000"/>
   <p:notesSz cx="6858000" cy="9144000"/>
   <p:defaultTextStyle>
     <a:defPPr>
@@ -115,6 +115,22 @@
       </a:defRPr>
     </a:lvl9pPr>
   </p:defaultTextStyle>
+  <p:extLst>
+    <p:ext uri="{EFAFB233-063F-42B5-8137-9DF3F51BA10A}">
+      <p15:sldGuideLst xmlns:p15="http://schemas.microsoft.com/office/powerpoint/2012/main">
+        <p15:guide id="1" orient="horz" pos="2160">
+          <p15:clr>
+            <a:srgbClr val="A4A3A4"/>
+          </p15:clr>
+        </p15:guide>
+        <p15:guide id="2" pos="2880">
+          <p15:clr>
+            <a:srgbClr val="A4A3A4"/>
+          </p15:clr>
+        </p15:guide>
+      </p15:sldGuideLst>
+    </p:ext>
+  </p:extLst>
 </p:presentation>
 </file>
 
@@ -156,10 +172,9 @@
           <a:lstStyle/>
           <a:p>
             <a:r>
-              <a:rPr lang="en-US" smtClean="0"/>
+              <a:rPr lang="en-US"/>
               <a:t>Click to edit Master title style</a:t>
             </a:r>
-            <a:endParaRPr lang="en-US"/>
           </a:p>
         </p:txBody>
       </p:sp>
@@ -275,10 +290,9 @@
           </a:lstStyle>
           <a:p>
             <a:r>
-              <a:rPr lang="en-US" smtClean="0"/>
+              <a:rPr lang="en-US"/>
               <a:t>Click to edit Master subtitle style</a:t>
             </a:r>
-            <a:endParaRPr lang="en-US"/>
           </a:p>
         </p:txBody>
       </p:sp>
@@ -299,7 +313,7 @@
           <a:p>
             <a:fld id="{5BCAD085-E8A6-8845-BD4E-CB4CCA059FC4}" type="datetimeFigureOut">
               <a:rPr lang="en-US" smtClean="0"/>
-              <a:t>1/27/13</a:t>
+              <a:t>8/21/2026</a:t>
             </a:fld>
             <a:endParaRPr lang="en-US"/>
           </a:p>
@@ -393,10 +407,9 @@
           <a:lstStyle/>
           <a:p>
             <a:r>
-              <a:rPr lang="en-US" smtClean="0"/>
+              <a:rPr lang="en-US"/>
               <a:t>Click to edit Master title style</a:t>
             </a:r>
-            <a:endParaRPr lang="en-US"/>
           </a:p>
         </p:txBody>
       </p:sp>
@@ -417,38 +430,37 @@
           <a:p>
             <a:pPr lvl="0"/>
             <a:r>
-              <a:rPr lang="en-US" smtClean="0"/>
+              <a:rPr lang="en-US"/>
               <a:t>Click to edit Master text styles</a:t>
             </a:r>
           </a:p>
           <a:p>
             <a:pPr lvl="1"/>
             <a:r>
-              <a:rPr lang="en-US" smtClean="0"/>
+              <a:rPr lang="en-US"/>
               <a:t>Second level</a:t>
             </a:r>
           </a:p>
           <a:p>
             <a:pPr lvl="2"/>
             <a:r>
-              <a:rPr lang="en-US" smtClean="0"/>
+              <a:rPr lang="en-US"/>
               <a:t>Third level</a:t>
             </a:r>
           </a:p>
           <a:p>
             <a:pPr lvl="3"/>
             <a:r>
-              <a:rPr lang="en-US" smtClean="0"/>
+              <a:rPr lang="en-US"/>
               <a:t>Fourth level</a:t>
             </a:r>
           </a:p>
           <a:p>
             <a:pPr lvl="4"/>
             <a:r>
-              <a:rPr lang="en-US" smtClean="0"/>
+              <a:rPr lang="en-US"/>
               <a:t>Fifth level</a:t>
             </a:r>
-            <a:endParaRPr lang="en-US"/>
           </a:p>
         </p:txBody>
       </p:sp>
@@ -469,7 +481,7 @@
           <a:p>
             <a:fld id="{5BCAD085-E8A6-8845-BD4E-CB4CCA059FC4}" type="datetimeFigureOut">
               <a:rPr lang="en-US" smtClean="0"/>
-              <a:t>1/27/13</a:t>
+              <a:t>8/21/2026</a:t>
             </a:fld>
             <a:endParaRPr lang="en-US"/>
           </a:p>
@@ -568,10 +580,9 @@
           <a:lstStyle/>
           <a:p>
             <a:r>
-              <a:rPr lang="en-US" smtClean="0"/>
+              <a:rPr lang="en-US"/>
               <a:t>Click to edit Master title style</a:t>
             </a:r>
-            <a:endParaRPr lang="en-US"/>
           </a:p>
         </p:txBody>
       </p:sp>
@@ -597,38 +608,37 @@
           <a:p>
             <a:pPr lvl="0"/>
             <a:r>
-              <a:rPr lang="en-US" smtClean="0"/>
+              <a:rPr lang="en-US"/>
               <a:t>Click to edit Master text styles</a:t>
             </a:r>
           </a:p>
           <a:p>
             <a:pPr lvl="1"/>
             <a:r>
-              <a:rPr lang="en-US" smtClean="0"/>
+              <a:rPr lang="en-US"/>
               <a:t>Second level</a:t>
             </a:r>
           </a:p>
           <a:p>
             <a:pPr lvl="2"/>
             <a:r>
-              <a:rPr lang="en-US" smtClean="0"/>
+              <a:rPr lang="en-US"/>
               <a:t>Third level</a:t>
             </a:r>
           </a:p>
           <a:p>
             <a:pPr lvl="3"/>
             <a:r>
-              <a:rPr lang="en-US" smtClean="0"/>
+              <a:rPr lang="en-US"/>
               <a:t>Fourth level</a:t>
             </a:r>
           </a:p>
           <a:p>
             <a:pPr lvl="4"/>
             <a:r>
-              <a:rPr lang="en-US" smtClean="0"/>
+              <a:rPr lang="en-US"/>
               <a:t>Fifth level</a:t>
             </a:r>
-            <a:endParaRPr lang="en-US"/>
           </a:p>
         </p:txBody>
       </p:sp>
@@ -649,7 +659,7 @@
           <a:p>
             <a:fld id="{5BCAD085-E8A6-8845-BD4E-CB4CCA059FC4}" type="datetimeFigureOut">
               <a:rPr lang="en-US" smtClean="0"/>
-              <a:t>1/27/13</a:t>
+              <a:t>8/21/2026</a:t>
             </a:fld>
             <a:endParaRPr lang="en-US"/>
           </a:p>
@@ -743,10 +753,9 @@
           <a:lstStyle/>
           <a:p>
             <a:r>
-              <a:rPr lang="en-US" smtClean="0"/>
+              <a:rPr lang="en-US"/>
               <a:t>Click to edit Master title style</a:t>
             </a:r>
-            <a:endParaRPr lang="en-US"/>
           </a:p>
         </p:txBody>
       </p:sp>
@@ -767,38 +776,37 @@
           <a:p>
             <a:pPr lvl="0"/>
             <a:r>
-              <a:rPr lang="en-US" smtClean="0"/>
+              <a:rPr lang="en-US"/>
               <a:t>Click to edit Master text styles</a:t>
             </a:r>
           </a:p>
           <a:p>
             <a:pPr lvl="1"/>
             <a:r>
-              <a:rPr lang="en-US" smtClean="0"/>
+              <a:rPr lang="en-US"/>
               <a:t>Second level</a:t>
             </a:r>
           </a:p>
           <a:p>
             <a:pPr lvl="2"/>
             <a:r>
-              <a:rPr lang="en-US" smtClean="0"/>
+              <a:rPr lang="en-US"/>
               <a:t>Third level</a:t>
             </a:r>
           </a:p>
           <a:p>
             <a:pPr lvl="3"/>
             <a:r>
-              <a:rPr lang="en-US" smtClean="0"/>
+              <a:rPr lang="en-US"/>
               <a:t>Fourth level</a:t>
             </a:r>
           </a:p>
           <a:p>
             <a:pPr lvl="4"/>
             <a:r>
-              <a:rPr lang="en-US" smtClean="0"/>
+              <a:rPr lang="en-US"/>
               <a:t>Fifth level</a:t>
             </a:r>
-            <a:endParaRPr lang="en-US"/>
           </a:p>
         </p:txBody>
       </p:sp>
@@ -819,7 +827,7 @@
           <a:p>
             <a:fld id="{5BCAD085-E8A6-8845-BD4E-CB4CCA059FC4}" type="datetimeFigureOut">
               <a:rPr lang="en-US" smtClean="0"/>
-              <a:t>1/27/13</a:t>
+              <a:t>8/21/2026</a:t>
             </a:fld>
             <a:endParaRPr lang="en-US"/>
           </a:p>
@@ -922,10 +930,9 @@
           </a:lstStyle>
           <a:p>
             <a:r>
-              <a:rPr lang="en-US" smtClean="0"/>
+              <a:rPr lang="en-US"/>
               <a:t>Click to edit Master title style</a:t>
             </a:r>
-            <a:endParaRPr lang="en-US"/>
           </a:p>
         </p:txBody>
       </p:sp>
@@ -1042,7 +1049,7 @@
           <a:p>
             <a:pPr lvl="0"/>
             <a:r>
-              <a:rPr lang="en-US" smtClean="0"/>
+              <a:rPr lang="en-US"/>
               <a:t>Click to edit Master text styles</a:t>
             </a:r>
           </a:p>
@@ -1065,7 +1072,7 @@
           <a:p>
             <a:fld id="{5BCAD085-E8A6-8845-BD4E-CB4CCA059FC4}" type="datetimeFigureOut">
               <a:rPr lang="en-US" smtClean="0"/>
-              <a:t>1/27/13</a:t>
+              <a:t>8/21/2026</a:t>
             </a:fld>
             <a:endParaRPr lang="en-US"/>
           </a:p>
@@ -1159,10 +1166,9 @@
           <a:lstStyle/>
           <a:p>
             <a:r>
-              <a:rPr lang="en-US" smtClean="0"/>
+              <a:rPr lang="en-US"/>
               <a:t>Click to edit Master title style</a:t>
             </a:r>
-            <a:endParaRPr lang="en-US"/>
           </a:p>
         </p:txBody>
       </p:sp>
@@ -1216,38 +1222,37 @@
           <a:p>
             <a:pPr lvl="0"/>
             <a:r>
-              <a:rPr lang="en-US" smtClean="0"/>
+              <a:rPr lang="en-US"/>
               <a:t>Click to edit Master text styles</a:t>
             </a:r>
           </a:p>
           <a:p>
             <a:pPr lvl="1"/>
             <a:r>
-              <a:rPr lang="en-US" smtClean="0"/>
+              <a:rPr lang="en-US"/>
               <a:t>Second level</a:t>
             </a:r>
           </a:p>
           <a:p>
             <a:pPr lvl="2"/>
             <a:r>
-              <a:rPr lang="en-US" smtClean="0"/>
+              <a:rPr lang="en-US"/>
               <a:t>Third level</a:t>
             </a:r>
           </a:p>
           <a:p>
             <a:pPr lvl="3"/>
             <a:r>
-              <a:rPr lang="en-US" smtClean="0"/>
+              <a:rPr lang="en-US"/>
               <a:t>Fourth level</a:t>
             </a:r>
           </a:p>
           <a:p>
             <a:pPr lvl="4"/>
             <a:r>
-              <a:rPr lang="en-US" smtClean="0"/>
+              <a:rPr lang="en-US"/>
               <a:t>Fifth level</a:t>
             </a:r>
-            <a:endParaRPr lang="en-US"/>
           </a:p>
         </p:txBody>
       </p:sp>
@@ -1301,38 +1306,37 @@
           <a:p>
             <a:pPr lvl="0"/>
             <a:r>
-              <a:rPr lang="en-US" smtClean="0"/>
+              <a:rPr lang="en-US"/>
               <a:t>Click to edit Master text styles</a:t>
             </a:r>
           </a:p>
           <a:p>
             <a:pPr lvl="1"/>
             <a:r>
-              <a:rPr lang="en-US" smtClean="0"/>
+              <a:rPr lang="en-US"/>
               <a:t>Second level</a:t>
             </a:r>
           </a:p>
           <a:p>
             <a:pPr lvl="2"/>
             <a:r>
-              <a:rPr lang="en-US" smtClean="0"/>
+              <a:rPr lang="en-US"/>
               <a:t>Third level</a:t>
             </a:r>
           </a:p>
           <a:p>
             <a:pPr lvl="3"/>
             <a:r>
-              <a:rPr lang="en-US" smtClean="0"/>
+              <a:rPr lang="en-US"/>
               <a:t>Fourth level</a:t>
             </a:r>
           </a:p>
           <a:p>
             <a:pPr lvl="4"/>
             <a:r>
-              <a:rPr lang="en-US" smtClean="0"/>
+              <a:rPr lang="en-US"/>
               <a:t>Fifth level</a:t>
             </a:r>
-            <a:endParaRPr lang="en-US"/>
           </a:p>
         </p:txBody>
       </p:sp>
@@ -1353,7 +1357,7 @@
           <a:p>
             <a:fld id="{5BCAD085-E8A6-8845-BD4E-CB4CCA059FC4}" type="datetimeFigureOut">
               <a:rPr lang="en-US" smtClean="0"/>
-              <a:t>1/27/13</a:t>
+              <a:t>8/21/2026</a:t>
             </a:fld>
             <a:endParaRPr lang="en-US"/>
           </a:p>
@@ -1451,10 +1455,9 @@
           </a:lstStyle>
           <a:p>
             <a:r>
-              <a:rPr lang="en-US" smtClean="0"/>
+              <a:rPr lang="en-US"/>
               <a:t>Click to edit Master title style</a:t>
             </a:r>
-            <a:endParaRPr lang="en-US"/>
           </a:p>
         </p:txBody>
       </p:sp>
@@ -1517,7 +1520,7 @@
           <a:p>
             <a:pPr lvl="0"/>
             <a:r>
-              <a:rPr lang="en-US" smtClean="0"/>
+              <a:rPr lang="en-US"/>
               <a:t>Click to edit Master text styles</a:t>
             </a:r>
           </a:p>
@@ -1573,38 +1576,37 @@
           <a:p>
             <a:pPr lvl="0"/>
             <a:r>
-              <a:rPr lang="en-US" smtClean="0"/>
+              <a:rPr lang="en-US"/>
               <a:t>Click to edit Master text styles</a:t>
             </a:r>
           </a:p>
           <a:p>
             <a:pPr lvl="1"/>
             <a:r>
-              <a:rPr lang="en-US" smtClean="0"/>
+              <a:rPr lang="en-US"/>
               <a:t>Second level</a:t>
             </a:r>
           </a:p>
           <a:p>
             <a:pPr lvl="2"/>
             <a:r>
-              <a:rPr lang="en-US" smtClean="0"/>
+              <a:rPr lang="en-US"/>
               <a:t>Third level</a:t>
             </a:r>
           </a:p>
           <a:p>
             <a:pPr lvl="3"/>
             <a:r>
-              <a:rPr lang="en-US" smtClean="0"/>
+              <a:rPr lang="en-US"/>
               <a:t>Fourth level</a:t>
             </a:r>
           </a:p>
           <a:p>
             <a:pPr lvl="4"/>
             <a:r>
-              <a:rPr lang="en-US" smtClean="0"/>
+              <a:rPr lang="en-US"/>
               <a:t>Fifth level</a:t>
             </a:r>
-            <a:endParaRPr lang="en-US"/>
           </a:p>
         </p:txBody>
       </p:sp>
@@ -1667,7 +1669,7 @@
           <a:p>
             <a:pPr lvl="0"/>
             <a:r>
-              <a:rPr lang="en-US" smtClean="0"/>
+              <a:rPr lang="en-US"/>
               <a:t>Click to edit Master text styles</a:t>
             </a:r>
           </a:p>
@@ -1723,38 +1725,37 @@
           <a:p>
             <a:pPr lvl="0"/>
             <a:r>
-              <a:rPr lang="en-US" smtClean="0"/>
+              <a:rPr lang="en-US"/>
               <a:t>Click to edit Master text styles</a:t>
             </a:r>
           </a:p>
           <a:p>
             <a:pPr lvl="1"/>
             <a:r>
-              <a:rPr lang="en-US" smtClean="0"/>
+              <a:rPr lang="en-US"/>
               <a:t>Second level</a:t>
             </a:r>
           </a:p>
           <a:p>
             <a:pPr lvl="2"/>
             <a:r>
-              <a:rPr lang="en-US" smtClean="0"/>
+              <a:rPr lang="en-US"/>
               <a:t>Third level</a:t>
             </a:r>
           </a:p>
           <a:p>
             <a:pPr lvl="3"/>
             <a:r>
-              <a:rPr lang="en-US" smtClean="0"/>
+              <a:rPr lang="en-US"/>
               <a:t>Fourth level</a:t>
             </a:r>
           </a:p>
           <a:p>
             <a:pPr lvl="4"/>
             <a:r>
-              <a:rPr lang="en-US" smtClean="0"/>
+              <a:rPr lang="en-US"/>
               <a:t>Fifth level</a:t>
             </a:r>
-            <a:endParaRPr lang="en-US"/>
           </a:p>
         </p:txBody>
       </p:sp>
@@ -1775,7 +1776,7 @@
           <a:p>
             <a:fld id="{5BCAD085-E8A6-8845-BD4E-CB4CCA059FC4}" type="datetimeFigureOut">
               <a:rPr lang="en-US" smtClean="0"/>
-              <a:t>1/27/13</a:t>
+              <a:t>8/21/2026</a:t>
             </a:fld>
             <a:endParaRPr lang="en-US"/>
           </a:p>
@@ -1869,10 +1870,9 @@
           <a:lstStyle/>
           <a:p>
             <a:r>
-              <a:rPr lang="en-US" smtClean="0"/>
+              <a:rPr lang="en-US"/>
               <a:t>Click to edit Master title style</a:t>
             </a:r>
-            <a:endParaRPr lang="en-US"/>
           </a:p>
         </p:txBody>
       </p:sp>
@@ -1893,7 +1893,7 @@
           <a:p>
             <a:fld id="{5BCAD085-E8A6-8845-BD4E-CB4CCA059FC4}" type="datetimeFigureOut">
               <a:rPr lang="en-US" smtClean="0"/>
-              <a:t>1/27/13</a:t>
+              <a:t>8/21/2026</a:t>
             </a:fld>
             <a:endParaRPr lang="en-US"/>
           </a:p>
@@ -1988,7 +1988,7 @@
           <a:p>
             <a:fld id="{5BCAD085-E8A6-8845-BD4E-CB4CCA059FC4}" type="datetimeFigureOut">
               <a:rPr lang="en-US" smtClean="0"/>
-              <a:t>1/27/13</a:t>
+              <a:t>8/21/2026</a:t>
             </a:fld>
             <a:endParaRPr lang="en-US"/>
           </a:p>
@@ -2091,10 +2091,9 @@
           </a:lstStyle>
           <a:p>
             <a:r>
-              <a:rPr lang="en-US" smtClean="0"/>
+              <a:rPr lang="en-US"/>
               <a:t>Click to edit Master title style</a:t>
             </a:r>
-            <a:endParaRPr lang="en-US"/>
           </a:p>
         </p:txBody>
       </p:sp>
@@ -2148,38 +2147,37 @@
           <a:p>
             <a:pPr lvl="0"/>
             <a:r>
-              <a:rPr lang="en-US" smtClean="0"/>
+              <a:rPr lang="en-US"/>
               <a:t>Click to edit Master text styles</a:t>
             </a:r>
           </a:p>
           <a:p>
             <a:pPr lvl="1"/>
             <a:r>
-              <a:rPr lang="en-US" smtClean="0"/>
+              <a:rPr lang="en-US"/>
               <a:t>Second level</a:t>
             </a:r>
           </a:p>
           <a:p>
             <a:pPr lvl="2"/>
             <a:r>
-              <a:rPr lang="en-US" smtClean="0"/>
+              <a:rPr lang="en-US"/>
               <a:t>Third level</a:t>
             </a:r>
           </a:p>
           <a:p>
             <a:pPr lvl="3"/>
             <a:r>
-              <a:rPr lang="en-US" smtClean="0"/>
+              <a:rPr lang="en-US"/>
               <a:t>Fourth level</a:t>
             </a:r>
           </a:p>
           <a:p>
             <a:pPr lvl="4"/>
             <a:r>
-              <a:rPr lang="en-US" smtClean="0"/>
+              <a:rPr lang="en-US"/>
               <a:t>Fifth level</a:t>
             </a:r>
-            <a:endParaRPr lang="en-US"/>
           </a:p>
         </p:txBody>
       </p:sp>
@@ -2242,7 +2240,7 @@
           <a:p>
             <a:pPr lvl="0"/>
             <a:r>
-              <a:rPr lang="en-US" smtClean="0"/>
+              <a:rPr lang="en-US"/>
               <a:t>Click to edit Master text styles</a:t>
             </a:r>
           </a:p>
@@ -2265,7 +2263,7 @@
           <a:p>
             <a:fld id="{5BCAD085-E8A6-8845-BD4E-CB4CCA059FC4}" type="datetimeFigureOut">
               <a:rPr lang="en-US" smtClean="0"/>
-              <a:t>1/27/13</a:t>
+              <a:t>8/21/2026</a:t>
             </a:fld>
             <a:endParaRPr lang="en-US"/>
           </a:p>
@@ -2368,10 +2366,9 @@
           </a:lstStyle>
           <a:p>
             <a:r>
-              <a:rPr lang="en-US" smtClean="0"/>
+              <a:rPr lang="en-US"/>
               <a:t>Click to edit Master title style</a:t>
             </a:r>
-            <a:endParaRPr lang="en-US"/>
           </a:p>
         </p:txBody>
       </p:sp>
@@ -2495,7 +2492,7 @@
           <a:p>
             <a:pPr lvl="0"/>
             <a:r>
-              <a:rPr lang="en-US" smtClean="0"/>
+              <a:rPr lang="en-US"/>
               <a:t>Click to edit Master text styles</a:t>
             </a:r>
           </a:p>
@@ -2518,7 +2515,7 @@
           <a:p>
             <a:fld id="{5BCAD085-E8A6-8845-BD4E-CB4CCA059FC4}" type="datetimeFigureOut">
               <a:rPr lang="en-US" smtClean="0"/>
-              <a:t>1/27/13</a:t>
+              <a:t>8/21/2026</a:t>
             </a:fld>
             <a:endParaRPr lang="en-US"/>
           </a:p>
@@ -2627,10 +2624,9 @@
           <a:lstStyle/>
           <a:p>
             <a:r>
-              <a:rPr lang="en-US" smtClean="0"/>
+              <a:rPr lang="en-US"/>
               <a:t>Click to edit Master title style</a:t>
             </a:r>
-            <a:endParaRPr lang="en-US"/>
           </a:p>
         </p:txBody>
       </p:sp>
@@ -2661,38 +2657,37 @@
           <a:p>
             <a:pPr lvl="0"/>
             <a:r>
-              <a:rPr lang="en-US" smtClean="0"/>
+              <a:rPr lang="en-US"/>
               <a:t>Click to edit Master text styles</a:t>
             </a:r>
           </a:p>
           <a:p>
             <a:pPr lvl="1"/>
             <a:r>
-              <a:rPr lang="en-US" smtClean="0"/>
+              <a:rPr lang="en-US"/>
               <a:t>Second level</a:t>
             </a:r>
           </a:p>
           <a:p>
             <a:pPr lvl="2"/>
             <a:r>
-              <a:rPr lang="en-US" smtClean="0"/>
+              <a:rPr lang="en-US"/>
               <a:t>Third level</a:t>
             </a:r>
           </a:p>
           <a:p>
             <a:pPr lvl="3"/>
             <a:r>
-              <a:rPr lang="en-US" smtClean="0"/>
+              <a:rPr lang="en-US"/>
               <a:t>Fourth level</a:t>
             </a:r>
           </a:p>
           <a:p>
             <a:pPr lvl="4"/>
             <a:r>
-              <a:rPr lang="en-US" smtClean="0"/>
+              <a:rPr lang="en-US"/>
               <a:t>Fifth level</a:t>
             </a:r>
-            <a:endParaRPr lang="en-US"/>
           </a:p>
         </p:txBody>
       </p:sp>
@@ -2731,7 +2726,7 @@
           <a:p>
             <a:fld id="{5BCAD085-E8A6-8845-BD4E-CB4CCA059FC4}" type="datetimeFigureOut">
               <a:rPr lang="en-US" smtClean="0"/>
-              <a:t>1/27/13</a:t>
+              <a:t>8/21/2026</a:t>
             </a:fld>
             <a:endParaRPr lang="en-US"/>
           </a:p>
@@ -3090,7 +3085,7 @@
 </file>
 
 <file path=ppt/slides/slide1.xml><?xml version="1.0" encoding="utf-8"?>
-<p:sld xmlns:a="http://schemas.openxmlformats.org/drawingml/2006/main" xmlns:p="http://schemas.openxmlformats.org/presentationml/2006/main" xmlns:r="http://schemas.openxmlformats.org/officeDocument/2006/relationships">
+<p:sld xmlns:a="http://schemas.openxmlformats.org/drawingml/2006/main" xmlns:r="http://schemas.openxmlformats.org/officeDocument/2006/relationships" xmlns:p="http://schemas.openxmlformats.org/presentationml/2006/main">
   <p:cSld>
     <p:bg>
       <p:bgPr>
@@ -3106,7 +3101,14 @@
         <p:cNvGrpSpPr/>
         <p:nvPr/>
       </p:nvGrpSpPr>
-      <p:grpSpPr/>
+      <p:grpSpPr>
+        <a:xfrm>
+          <a:off x="0" y="0"/>
+          <a:ext cx="0" cy="0"/>
+          <a:chOff x="0" y="0"/>
+          <a:chExt cx="0" cy="0"/>
+        </a:xfrm>
+      </p:grpSpPr>
       <p:sp>
         <p:nvSpPr>
           <p:cNvPr id="2" name="TextBox 1"/>
@@ -3141,7 +3143,7 @@
               </a:spcAft>
             </a:pPr>
             <a:r>
-              <a:rPr sz="3400" b="1" i="0">
+              <a:rPr sz="3400" b="1" i="0" dirty="0">
                 <a:solidFill>
                   <a:srgbClr val="111111"/>
                 </a:solidFill>
@@ -3331,7 +3333,7 @@
         <p:spPr>
           <a:xfrm>
             <a:off x="694944" y="4846320"/>
-            <a:ext cx="5303520" cy="274320"/>
+            <a:ext cx="5303520" cy="292388"/>
           </a:xfrm>
           <a:prstGeom prst="rect">
             <a:avLst/>
@@ -3356,14 +3358,38 @@
               </a:spcAft>
             </a:pPr>
             <a:r>
-              <a:rPr sz="1300" b="0" i="0">
+              <a:rPr lang="en-US" sz="1300" b="0" i="0" dirty="0">
                 <a:solidFill>
                   <a:srgbClr val="555555"/>
                 </a:solidFill>
                 <a:latin typeface="Arial"/>
               </a:rPr>
-              <a:t>Review window: 18–22 August 2026</a:t>
-            </a:r>
+              <a:t>22</a:t>
+            </a:r>
+            <a:r>
+              <a:rPr lang="en-US" sz="1300" b="0" i="0" baseline="30000" dirty="0">
+                <a:solidFill>
+                  <a:srgbClr val="555555"/>
+                </a:solidFill>
+                <a:latin typeface="Arial"/>
+              </a:rPr>
+              <a:t>nd</a:t>
+            </a:r>
+            <a:r>
+              <a:rPr lang="en-US" sz="1300" b="0" i="0" dirty="0">
+                <a:solidFill>
+                  <a:srgbClr val="555555"/>
+                </a:solidFill>
+                <a:latin typeface="Arial"/>
+              </a:rPr>
+              <a:t> August 2026</a:t>
+            </a:r>
+            <a:endParaRPr sz="1300" b="0" i="0" dirty="0">
+              <a:solidFill>
+                <a:srgbClr val="555555"/>
+              </a:solidFill>
+              <a:latin typeface="Arial"/>
+            </a:endParaRPr>
           </a:p>
         </p:txBody>
       </p:sp>
@@ -3375,8 +3401,8 @@
         </p:nvSpPr>
         <p:spPr>
           <a:xfrm>
-            <a:off x="694944" y="5248656"/>
-            <a:ext cx="5303520" cy="274320"/>
+            <a:off x="694944" y="5248657"/>
+            <a:ext cx="5303520" cy="292388"/>
           </a:xfrm>
           <a:prstGeom prst="rect">
             <a:avLst/>
@@ -3401,14 +3427,20 @@
               </a:spcAft>
             </a:pPr>
             <a:r>
-              <a:rPr sz="1300" b="0" i="0">
+              <a:rPr lang="en-US" sz="1300" b="0" i="0" dirty="0">
                 <a:solidFill>
                   <a:srgbClr val="555555"/>
                 </a:solidFill>
                 <a:latin typeface="Arial"/>
               </a:rPr>
-              <a:t>Presentation slot: 15 minutes</a:t>
-            </a:r>
+              <a:t>Guide: Dr. Udit Narayana Kar</a:t>
+            </a:r>
+            <a:endParaRPr sz="1300" b="0" i="0" dirty="0">
+              <a:solidFill>
+                <a:srgbClr val="555555"/>
+              </a:solidFill>
+              <a:latin typeface="Arial"/>
+            </a:endParaRPr>
           </a:p>
         </p:txBody>
       </p:sp>
@@ -3421,7 +3453,7 @@
         <p:spPr>
           <a:xfrm>
             <a:off x="7406640" y="5230368"/>
-            <a:ext cx="3749039" cy="329184"/>
+            <a:ext cx="3749039" cy="769441"/>
           </a:xfrm>
           <a:prstGeom prst="rect">
             <a:avLst/>
@@ -3446,14 +3478,86 @@
               </a:spcAft>
             </a:pPr>
             <a:r>
-              <a:rPr sz="1100" b="0" i="0">
+              <a:rPr lang="en-US" sz="1100" b="0" i="0" dirty="0">
                 <a:solidFill>
                   <a:srgbClr val="555555"/>
                 </a:solidFill>
                 <a:latin typeface="Arial"/>
               </a:rPr>
-              <a:t>Team and guide details to be added</a:t>
-            </a:r>
+              <a:t>Nishchal Ravi</a:t>
+            </a:r>
+          </a:p>
+          <a:p>
+            <a:pPr algn="r">
+              <a:lnSpc>
+                <a:spcPct val="100000"/>
+              </a:lnSpc>
+              <a:spcBef>
+                <a:spcPts val="0"/>
+              </a:spcBef>
+              <a:spcAft>
+                <a:spcPts val="0"/>
+              </a:spcAft>
+            </a:pPr>
+            <a:r>
+              <a:rPr lang="en-US" sz="1100" b="0" i="0" dirty="0">
+                <a:solidFill>
+                  <a:srgbClr val="555555"/>
+                </a:solidFill>
+                <a:latin typeface="Arial"/>
+              </a:rPr>
+              <a:t>Tanishq Srivastava</a:t>
+            </a:r>
+          </a:p>
+          <a:p>
+            <a:pPr algn="r">
+              <a:lnSpc>
+                <a:spcPct val="100000"/>
+              </a:lnSpc>
+              <a:spcBef>
+                <a:spcPts val="0"/>
+              </a:spcBef>
+              <a:spcAft>
+                <a:spcPts val="0"/>
+              </a:spcAft>
+            </a:pPr>
+            <a:r>
+              <a:rPr lang="en-US" sz="1100" b="0" i="0" dirty="0">
+                <a:solidFill>
+                  <a:srgbClr val="555555"/>
+                </a:solidFill>
+                <a:latin typeface="Arial"/>
+              </a:rPr>
+              <a:t>Amogh Mishra</a:t>
+            </a:r>
+          </a:p>
+          <a:p>
+            <a:pPr algn="r">
+              <a:lnSpc>
+                <a:spcPct val="100000"/>
+              </a:lnSpc>
+              <a:spcBef>
+                <a:spcPts val="0"/>
+              </a:spcBef>
+              <a:spcAft>
+                <a:spcPts val="0"/>
+              </a:spcAft>
+            </a:pPr>
+            <a:r>
+              <a:rPr lang="en-US" sz="1100" dirty="0">
+                <a:solidFill>
+                  <a:srgbClr val="555555"/>
+                </a:solidFill>
+                <a:latin typeface="Arial"/>
+              </a:rPr>
+              <a:t>Sreeparna Mukherjee</a:t>
+            </a:r>
+            <a:endParaRPr sz="1100" b="0" i="0" dirty="0">
+              <a:solidFill>
+                <a:srgbClr val="555555"/>
+              </a:solidFill>
+              <a:latin typeface="Arial"/>
+            </a:endParaRPr>
           </a:p>
         </p:txBody>
       </p:sp>
@@ -3636,7 +3740,7 @@
 </file>
 
 <file path=ppt/slides/slide10.xml><?xml version="1.0" encoding="utf-8"?>
-<p:sld xmlns:a="http://schemas.openxmlformats.org/drawingml/2006/main" xmlns:p="http://schemas.openxmlformats.org/presentationml/2006/main" xmlns:r="http://schemas.openxmlformats.org/officeDocument/2006/relationships">
+<p:sld xmlns:a="http://schemas.openxmlformats.org/drawingml/2006/main" xmlns:r="http://schemas.openxmlformats.org/officeDocument/2006/relationships" xmlns:p="http://schemas.openxmlformats.org/presentationml/2006/main">
   <p:cSld>
     <p:bg>
       <p:bgPr>
@@ -3652,7 +3756,14 @@
         <p:cNvGrpSpPr/>
         <p:nvPr/>
       </p:nvGrpSpPr>
-      <p:grpSpPr/>
+      <p:grpSpPr>
+        <a:xfrm>
+          <a:off x="0" y="0"/>
+          <a:ext cx="0" cy="0"/>
+          <a:chOff x="0" y="0"/>
+          <a:chExt cx="0" cy="0"/>
+        </a:xfrm>
+      </p:grpSpPr>
       <p:sp>
         <p:nvSpPr>
           <p:cNvPr id="2" name="TextBox 1"/>
@@ -3820,6 +3931,7 @@
           <a:lstStyle/>
           <a:p>
             <a:pPr algn="ctr"/>
+            <a:endParaRPr/>
           </a:p>
         </p:txBody>
       </p:sp>
@@ -3945,6 +4057,7 @@
           <a:lstStyle/>
           <a:p>
             <a:pPr algn="ctr"/>
+            <a:endParaRPr/>
           </a:p>
         </p:txBody>
       </p:sp>
@@ -4070,6 +4183,7 @@
           <a:lstStyle/>
           <a:p>
             <a:pPr algn="ctr"/>
+            <a:endParaRPr/>
           </a:p>
         </p:txBody>
       </p:sp>
@@ -4195,6 +4309,7 @@
           <a:lstStyle/>
           <a:p>
             <a:pPr algn="ctr"/>
+            <a:endParaRPr/>
           </a:p>
         </p:txBody>
       </p:sp>
@@ -4435,6 +4550,7 @@
           <a:lstStyle/>
           <a:p>
             <a:pPr algn="ctr"/>
+            <a:endParaRPr/>
           </a:p>
         </p:txBody>
       </p:sp>
@@ -4560,6 +4676,7 @@
           <a:lstStyle/>
           <a:p>
             <a:pPr algn="ctr"/>
+            <a:endParaRPr/>
           </a:p>
         </p:txBody>
       </p:sp>
@@ -4685,6 +4802,7 @@
           <a:lstStyle/>
           <a:p>
             <a:pPr algn="ctr"/>
+            <a:endParaRPr/>
           </a:p>
         </p:txBody>
       </p:sp>
@@ -4810,6 +4928,7 @@
           <a:lstStyle/>
           <a:p>
             <a:pPr algn="ctr"/>
+            <a:endParaRPr/>
           </a:p>
         </p:txBody>
       </p:sp>
@@ -4935,6 +5054,7 @@
           <a:lstStyle/>
           <a:p>
             <a:pPr algn="ctr"/>
+            <a:endParaRPr/>
           </a:p>
         </p:txBody>
       </p:sp>
@@ -5060,6 +5180,7 @@
           <a:lstStyle/>
           <a:p>
             <a:pPr algn="ctr"/>
+            <a:endParaRPr/>
           </a:p>
         </p:txBody>
       </p:sp>
@@ -5230,6 +5351,7 @@
           <a:lstStyle/>
           <a:p>
             <a:pPr algn="ctr"/>
+            <a:endParaRPr/>
           </a:p>
         </p:txBody>
       </p:sp>
@@ -5400,6 +5522,7 @@
           <a:lstStyle/>
           <a:p>
             <a:pPr algn="ctr"/>
+            <a:endParaRPr/>
           </a:p>
         </p:txBody>
       </p:sp>
@@ -5570,6 +5693,7 @@
           <a:lstStyle/>
           <a:p>
             <a:pPr algn="ctr"/>
+            <a:endParaRPr/>
           </a:p>
         </p:txBody>
       </p:sp>
@@ -5693,6 +5817,7 @@
           <a:lstStyle/>
           <a:p>
             <a:pPr algn="ctr"/>
+            <a:endParaRPr/>
           </a:p>
         </p:txBody>
       </p:sp>
@@ -5771,6 +5896,7 @@
           <a:lstStyle/>
           <a:p>
             <a:pPr algn="ctr"/>
+            <a:endParaRPr/>
           </a:p>
         </p:txBody>
       </p:sp>
@@ -5849,6 +5975,7 @@
           <a:lstStyle/>
           <a:p>
             <a:pPr algn="ctr"/>
+            <a:endParaRPr/>
           </a:p>
         </p:txBody>
       </p:sp>
@@ -5927,6 +6054,7 @@
           <a:lstStyle/>
           <a:p>
             <a:pPr algn="ctr"/>
+            <a:endParaRPr/>
           </a:p>
         </p:txBody>
       </p:sp>
@@ -5970,6 +6098,7 @@
           <a:lstStyle/>
           <a:p>
             <a:pPr algn="ctr"/>
+            <a:endParaRPr/>
           </a:p>
         </p:txBody>
       </p:sp>
@@ -6287,7 +6416,7 @@
 </file>
 
 <file path=ppt/slides/slide11.xml><?xml version="1.0" encoding="utf-8"?>
-<p:sld xmlns:a="http://schemas.openxmlformats.org/drawingml/2006/main" xmlns:p="http://schemas.openxmlformats.org/presentationml/2006/main" xmlns:r="http://schemas.openxmlformats.org/officeDocument/2006/relationships">
+<p:sld xmlns:a="http://schemas.openxmlformats.org/drawingml/2006/main" xmlns:r="http://schemas.openxmlformats.org/officeDocument/2006/relationships" xmlns:p="http://schemas.openxmlformats.org/presentationml/2006/main">
   <p:cSld>
     <p:bg>
       <p:bgPr>
@@ -6303,7 +6432,14 @@
         <p:cNvGrpSpPr/>
         <p:nvPr/>
       </p:nvGrpSpPr>
-      <p:grpSpPr/>
+      <p:grpSpPr>
+        <a:xfrm>
+          <a:off x="0" y="0"/>
+          <a:ext cx="0" cy="0"/>
+          <a:chOff x="0" y="0"/>
+          <a:chExt cx="0" cy="0"/>
+        </a:xfrm>
+      </p:grpSpPr>
       <p:sp>
         <p:nvSpPr>
           <p:cNvPr id="2" name="TextBox 1"/>
@@ -6426,6 +6562,7 @@
           <a:lstStyle/>
           <a:p>
             <a:pPr algn="ctr"/>
+            <a:endParaRPr/>
           </a:p>
         </p:txBody>
       </p:sp>
@@ -6561,6 +6698,7 @@
           <a:lstStyle/>
           <a:p>
             <a:pPr algn="ctr"/>
+            <a:endParaRPr/>
           </a:p>
         </p:txBody>
       </p:sp>
@@ -6696,6 +6834,7 @@
           <a:lstStyle/>
           <a:p>
             <a:pPr algn="ctr"/>
+            <a:endParaRPr/>
           </a:p>
         </p:txBody>
       </p:sp>
@@ -6941,6 +7080,7 @@
           <a:lstStyle/>
           <a:p>
             <a:pPr algn="ctr"/>
+            <a:endParaRPr/>
           </a:p>
         </p:txBody>
       </p:sp>
@@ -7168,7 +7308,7 @@
 </file>
 
 <file path=ppt/slides/slide12.xml><?xml version="1.0" encoding="utf-8"?>
-<p:sld xmlns:a="http://schemas.openxmlformats.org/drawingml/2006/main" xmlns:p="http://schemas.openxmlformats.org/presentationml/2006/main" xmlns:r="http://schemas.openxmlformats.org/officeDocument/2006/relationships">
+<p:sld xmlns:a="http://schemas.openxmlformats.org/drawingml/2006/main" xmlns:r="http://schemas.openxmlformats.org/officeDocument/2006/relationships" xmlns:p="http://schemas.openxmlformats.org/presentationml/2006/main">
   <p:cSld>
     <p:bg>
       <p:bgPr>
@@ -7184,7 +7324,14 @@
         <p:cNvGrpSpPr/>
         <p:nvPr/>
       </p:nvGrpSpPr>
-      <p:grpSpPr/>
+      <p:grpSpPr>
+        <a:xfrm>
+          <a:off x="0" y="0"/>
+          <a:ext cx="0" cy="0"/>
+          <a:chOff x="0" y="0"/>
+          <a:chExt cx="0" cy="0"/>
+        </a:xfrm>
+      </p:grpSpPr>
       <p:sp>
         <p:nvSpPr>
           <p:cNvPr id="2" name="TextBox 1"/>
@@ -8680,6 +8827,7 @@
           <a:lstStyle/>
           <a:p>
             <a:pPr algn="ctr"/>
+            <a:endParaRPr/>
           </a:p>
         </p:txBody>
       </p:sp>
@@ -8952,7 +9100,7 @@
 </file>
 
 <file path=ppt/slides/slide2.xml><?xml version="1.0" encoding="utf-8"?>
-<p:sld xmlns:a="http://schemas.openxmlformats.org/drawingml/2006/main" xmlns:p="http://schemas.openxmlformats.org/presentationml/2006/main" xmlns:r="http://schemas.openxmlformats.org/officeDocument/2006/relationships">
+<p:sld xmlns:a="http://schemas.openxmlformats.org/drawingml/2006/main" xmlns:r="http://schemas.openxmlformats.org/officeDocument/2006/relationships" xmlns:p="http://schemas.openxmlformats.org/presentationml/2006/main">
   <p:cSld>
     <p:bg>
       <p:bgPr>
@@ -8968,7 +9116,14 @@
         <p:cNvGrpSpPr/>
         <p:nvPr/>
       </p:nvGrpSpPr>
-      <p:grpSpPr/>
+      <p:grpSpPr>
+        <a:xfrm>
+          <a:off x="0" y="0"/>
+          <a:ext cx="0" cy="0"/>
+          <a:chOff x="0" y="0"/>
+          <a:chExt cx="0" cy="0"/>
+        </a:xfrm>
+      </p:grpSpPr>
       <p:sp>
         <p:nvSpPr>
           <p:cNvPr id="2" name="TextBox 1"/>
@@ -9091,6 +9246,7 @@
           <a:lstStyle/>
           <a:p>
             <a:pPr algn="ctr"/>
+            <a:endParaRPr/>
           </a:p>
         </p:txBody>
       </p:sp>
@@ -9271,6 +9427,7 @@
           <a:lstStyle/>
           <a:p>
             <a:pPr algn="ctr"/>
+            <a:endParaRPr/>
           </a:p>
         </p:txBody>
       </p:sp>
@@ -9451,6 +9608,7 @@
           <a:lstStyle/>
           <a:p>
             <a:pPr algn="ctr"/>
+            <a:endParaRPr/>
           </a:p>
         </p:txBody>
       </p:sp>
@@ -9631,6 +9789,7 @@
           <a:lstStyle/>
           <a:p>
             <a:pPr algn="ctr"/>
+            <a:endParaRPr/>
           </a:p>
         </p:txBody>
       </p:sp>
@@ -9809,6 +9968,7 @@
           <a:lstStyle/>
           <a:p>
             <a:pPr algn="ctr"/>
+            <a:endParaRPr/>
           </a:p>
         </p:txBody>
       </p:sp>
@@ -10126,7 +10286,7 @@
 </file>
 
 <file path=ppt/slides/slide3.xml><?xml version="1.0" encoding="utf-8"?>
-<p:sld xmlns:a="http://schemas.openxmlformats.org/drawingml/2006/main" xmlns:p="http://schemas.openxmlformats.org/presentationml/2006/main" xmlns:r="http://schemas.openxmlformats.org/officeDocument/2006/relationships">
+<p:sld xmlns:a="http://schemas.openxmlformats.org/drawingml/2006/main" xmlns:r="http://schemas.openxmlformats.org/officeDocument/2006/relationships" xmlns:p="http://schemas.openxmlformats.org/presentationml/2006/main">
   <p:cSld>
     <p:bg>
       <p:bgPr>
@@ -10142,7 +10302,14 @@
         <p:cNvGrpSpPr/>
         <p:nvPr/>
       </p:nvGrpSpPr>
-      <p:grpSpPr/>
+      <p:grpSpPr>
+        <a:xfrm>
+          <a:off x="0" y="0"/>
+          <a:ext cx="0" cy="0"/>
+          <a:chOff x="0" y="0"/>
+          <a:chExt cx="0" cy="0"/>
+        </a:xfrm>
+      </p:grpSpPr>
       <p:sp>
         <p:nvSpPr>
           <p:cNvPr id="2" name="TextBox 1"/>
@@ -10265,6 +10432,7 @@
           <a:lstStyle/>
           <a:p>
             <a:pPr algn="ctr"/>
+            <a:endParaRPr/>
           </a:p>
         </p:txBody>
       </p:sp>
@@ -10400,6 +10568,7 @@
           <a:lstStyle/>
           <a:p>
             <a:pPr algn="ctr"/>
+            <a:endParaRPr/>
           </a:p>
         </p:txBody>
       </p:sp>
@@ -10535,6 +10704,7 @@
           <a:lstStyle/>
           <a:p>
             <a:pPr algn="ctr"/>
+            <a:endParaRPr/>
           </a:p>
         </p:txBody>
       </p:sp>
@@ -10670,6 +10840,7 @@
           <a:lstStyle/>
           <a:p>
             <a:pPr algn="ctr"/>
+            <a:endParaRPr/>
           </a:p>
         </p:txBody>
       </p:sp>
@@ -10805,6 +10976,7 @@
           <a:lstStyle/>
           <a:p>
             <a:pPr algn="ctr"/>
+            <a:endParaRPr/>
           </a:p>
         </p:txBody>
       </p:sp>
@@ -10973,6 +11145,7 @@
           <a:lstStyle/>
           <a:p>
             <a:pPr algn="ctr"/>
+            <a:endParaRPr/>
           </a:p>
         </p:txBody>
       </p:sp>
@@ -11051,6 +11224,7 @@
           <a:lstStyle/>
           <a:p>
             <a:pPr algn="ctr"/>
+            <a:endParaRPr/>
           </a:p>
         </p:txBody>
       </p:sp>
@@ -11129,6 +11303,7 @@
           <a:lstStyle/>
           <a:p>
             <a:pPr algn="ctr"/>
+            <a:endParaRPr/>
           </a:p>
         </p:txBody>
       </p:sp>
@@ -11207,6 +11382,7 @@
           <a:lstStyle/>
           <a:p>
             <a:pPr algn="ctr"/>
+            <a:endParaRPr/>
           </a:p>
         </p:txBody>
       </p:sp>
@@ -11829,7 +12005,7 @@
 </file>
 
 <file path=ppt/slides/slide4.xml><?xml version="1.0" encoding="utf-8"?>
-<p:sld xmlns:a="http://schemas.openxmlformats.org/drawingml/2006/main" xmlns:p="http://schemas.openxmlformats.org/presentationml/2006/main" xmlns:r="http://schemas.openxmlformats.org/officeDocument/2006/relationships">
+<p:sld xmlns:a="http://schemas.openxmlformats.org/drawingml/2006/main" xmlns:r="http://schemas.openxmlformats.org/officeDocument/2006/relationships" xmlns:p="http://schemas.openxmlformats.org/presentationml/2006/main">
   <p:cSld>
     <p:bg>
       <p:bgPr>
@@ -11845,7 +12021,14 @@
         <p:cNvGrpSpPr/>
         <p:nvPr/>
       </p:nvGrpSpPr>
-      <p:grpSpPr/>
+      <p:grpSpPr>
+        <a:xfrm>
+          <a:off x="0" y="0"/>
+          <a:ext cx="0" cy="0"/>
+          <a:chOff x="0" y="0"/>
+          <a:chExt cx="0" cy="0"/>
+        </a:xfrm>
+      </p:grpSpPr>
       <p:sp>
         <p:nvSpPr>
           <p:cNvPr id="2" name="TextBox 1"/>
@@ -11968,6 +12151,7 @@
           <a:lstStyle/>
           <a:p>
             <a:pPr algn="ctr"/>
+            <a:endParaRPr/>
           </a:p>
         </p:txBody>
       </p:sp>
@@ -12103,6 +12287,7 @@
           <a:lstStyle/>
           <a:p>
             <a:pPr algn="ctr"/>
+            <a:endParaRPr/>
           </a:p>
         </p:txBody>
       </p:sp>
@@ -12238,6 +12423,7 @@
           <a:lstStyle/>
           <a:p>
             <a:pPr algn="ctr"/>
+            <a:endParaRPr/>
           </a:p>
         </p:txBody>
       </p:sp>
@@ -12373,6 +12559,7 @@
           <a:lstStyle/>
           <a:p>
             <a:pPr algn="ctr"/>
+            <a:endParaRPr/>
           </a:p>
         </p:txBody>
       </p:sp>
@@ -12508,6 +12695,7 @@
           <a:lstStyle/>
           <a:p>
             <a:pPr algn="ctr"/>
+            <a:endParaRPr/>
           </a:p>
         </p:txBody>
       </p:sp>
@@ -12676,6 +12864,7 @@
           <a:lstStyle/>
           <a:p>
             <a:pPr algn="ctr"/>
+            <a:endParaRPr/>
           </a:p>
         </p:txBody>
       </p:sp>
@@ -12754,6 +12943,7 @@
           <a:lstStyle/>
           <a:p>
             <a:pPr algn="ctr"/>
+            <a:endParaRPr/>
           </a:p>
         </p:txBody>
       </p:sp>
@@ -12832,6 +13022,7 @@
           <a:lstStyle/>
           <a:p>
             <a:pPr algn="ctr"/>
+            <a:endParaRPr/>
           </a:p>
         </p:txBody>
       </p:sp>
@@ -12910,6 +13101,7 @@
           <a:lstStyle/>
           <a:p>
             <a:pPr algn="ctr"/>
+            <a:endParaRPr/>
           </a:p>
         </p:txBody>
       </p:sp>
@@ -13168,6 +13360,7 @@
           <a:lstStyle/>
           <a:p>
             <a:pPr algn="ctr"/>
+            <a:endParaRPr/>
           </a:p>
         </p:txBody>
       </p:sp>
@@ -13440,7 +13633,7 @@
 </file>
 
 <file path=ppt/slides/slide5.xml><?xml version="1.0" encoding="utf-8"?>
-<p:sld xmlns:a="http://schemas.openxmlformats.org/drawingml/2006/main" xmlns:p="http://schemas.openxmlformats.org/presentationml/2006/main" xmlns:r="http://schemas.openxmlformats.org/officeDocument/2006/relationships">
+<p:sld xmlns:a="http://schemas.openxmlformats.org/drawingml/2006/main" xmlns:r="http://schemas.openxmlformats.org/officeDocument/2006/relationships" xmlns:p="http://schemas.openxmlformats.org/presentationml/2006/main">
   <p:cSld>
     <p:bg>
       <p:bgPr>
@@ -13456,7 +13649,14 @@
         <p:cNvGrpSpPr/>
         <p:nvPr/>
       </p:nvGrpSpPr>
-      <p:grpSpPr/>
+      <p:grpSpPr>
+        <a:xfrm>
+          <a:off x="0" y="0"/>
+          <a:ext cx="0" cy="0"/>
+          <a:chOff x="0" y="0"/>
+          <a:chExt cx="0" cy="0"/>
+        </a:xfrm>
+      </p:grpSpPr>
       <p:sp>
         <p:nvSpPr>
           <p:cNvPr id="2" name="TextBox 1"/>
@@ -14486,7 +14686,7 @@
 </file>
 
 <file path=ppt/slides/slide6.xml><?xml version="1.0" encoding="utf-8"?>
-<p:sld xmlns:a="http://schemas.openxmlformats.org/drawingml/2006/main" xmlns:p="http://schemas.openxmlformats.org/presentationml/2006/main" xmlns:r="http://schemas.openxmlformats.org/officeDocument/2006/relationships">
+<p:sld xmlns:a="http://schemas.openxmlformats.org/drawingml/2006/main" xmlns:r="http://schemas.openxmlformats.org/officeDocument/2006/relationships" xmlns:p="http://schemas.openxmlformats.org/presentationml/2006/main">
   <p:cSld>
     <p:bg>
       <p:bgPr>
@@ -14502,7 +14702,14 @@
         <p:cNvGrpSpPr/>
         <p:nvPr/>
       </p:nvGrpSpPr>
-      <p:grpSpPr/>
+      <p:grpSpPr>
+        <a:xfrm>
+          <a:off x="0" y="0"/>
+          <a:ext cx="0" cy="0"/>
+          <a:chOff x="0" y="0"/>
+          <a:chExt cx="0" cy="0"/>
+        </a:xfrm>
+      </p:grpSpPr>
       <p:sp>
         <p:nvSpPr>
           <p:cNvPr id="2" name="TextBox 1"/>
@@ -15278,6 +15485,7 @@
           <a:lstStyle/>
           <a:p>
             <a:pPr algn="ctr"/>
+            <a:endParaRPr/>
           </a:p>
         </p:txBody>
       </p:sp>
@@ -15505,7 +15713,7 @@
 </file>
 
 <file path=ppt/slides/slide7.xml><?xml version="1.0" encoding="utf-8"?>
-<p:sld xmlns:a="http://schemas.openxmlformats.org/drawingml/2006/main" xmlns:p="http://schemas.openxmlformats.org/presentationml/2006/main" xmlns:r="http://schemas.openxmlformats.org/officeDocument/2006/relationships">
+<p:sld xmlns:a="http://schemas.openxmlformats.org/drawingml/2006/main" xmlns:r="http://schemas.openxmlformats.org/officeDocument/2006/relationships" xmlns:p="http://schemas.openxmlformats.org/presentationml/2006/main">
   <p:cSld>
     <p:bg>
       <p:bgPr>
@@ -15521,7 +15729,14 @@
         <p:cNvGrpSpPr/>
         <p:nvPr/>
       </p:nvGrpSpPr>
-      <p:grpSpPr/>
+      <p:grpSpPr>
+        <a:xfrm>
+          <a:off x="0" y="0"/>
+          <a:ext cx="0" cy="0"/>
+          <a:chOff x="0" y="0"/>
+          <a:chExt cx="0" cy="0"/>
+        </a:xfrm>
+      </p:grpSpPr>
       <p:sp>
         <p:nvSpPr>
           <p:cNvPr id="2" name="TextBox 1"/>
@@ -15642,6 +15857,7 @@
           <a:lstStyle/>
           <a:p>
             <a:pPr algn="ctr"/>
+            <a:endParaRPr/>
           </a:p>
         </p:txBody>
       </p:sp>
@@ -15732,6 +15948,7 @@
           <a:lstStyle/>
           <a:p>
             <a:pPr algn="ctr"/>
+            <a:endParaRPr/>
           </a:p>
         </p:txBody>
       </p:sp>
@@ -15982,6 +16199,7 @@
           <a:lstStyle/>
           <a:p>
             <a:pPr algn="ctr"/>
+            <a:endParaRPr/>
           </a:p>
         </p:txBody>
       </p:sp>
@@ -16232,6 +16450,7 @@
           <a:lstStyle/>
           <a:p>
             <a:pPr algn="ctr"/>
+            <a:endParaRPr/>
           </a:p>
         </p:txBody>
       </p:sp>
@@ -16482,6 +16701,7 @@
           <a:lstStyle/>
           <a:p>
             <a:pPr algn="ctr"/>
+            <a:endParaRPr/>
           </a:p>
         </p:txBody>
       </p:sp>
@@ -16820,6 +17040,7 @@
           <a:lstStyle/>
           <a:p>
             <a:pPr algn="ctr"/>
+            <a:endParaRPr/>
           </a:p>
         </p:txBody>
       </p:sp>
@@ -17047,7 +17268,7 @@
 </file>
 
 <file path=ppt/slides/slide8.xml><?xml version="1.0" encoding="utf-8"?>
-<p:sld xmlns:a="http://schemas.openxmlformats.org/drawingml/2006/main" xmlns:p="http://schemas.openxmlformats.org/presentationml/2006/main" xmlns:r="http://schemas.openxmlformats.org/officeDocument/2006/relationships">
+<p:sld xmlns:a="http://schemas.openxmlformats.org/drawingml/2006/main" xmlns:r="http://schemas.openxmlformats.org/officeDocument/2006/relationships" xmlns:p="http://schemas.openxmlformats.org/presentationml/2006/main">
   <p:cSld>
     <p:bg>
       <p:bgPr>
@@ -17063,7 +17284,14 @@
         <p:cNvGrpSpPr/>
         <p:nvPr/>
       </p:nvGrpSpPr>
-      <p:grpSpPr/>
+      <p:grpSpPr>
+        <a:xfrm>
+          <a:off x="0" y="0"/>
+          <a:ext cx="0" cy="0"/>
+          <a:chOff x="0" y="0"/>
+          <a:chExt cx="0" cy="0"/>
+        </a:xfrm>
+      </p:grpSpPr>
       <p:sp>
         <p:nvSpPr>
           <p:cNvPr id="2" name="TextBox 1"/>
@@ -17819,6 +18047,7 @@
           <a:lstStyle/>
           <a:p>
             <a:pPr algn="ctr"/>
+            <a:endParaRPr/>
           </a:p>
         </p:txBody>
       </p:sp>
@@ -18046,7 +18275,7 @@
 </file>
 
 <file path=ppt/slides/slide9.xml><?xml version="1.0" encoding="utf-8"?>
-<p:sld xmlns:a="http://schemas.openxmlformats.org/drawingml/2006/main" xmlns:p="http://schemas.openxmlformats.org/presentationml/2006/main" xmlns:r="http://schemas.openxmlformats.org/officeDocument/2006/relationships">
+<p:sld xmlns:a="http://schemas.openxmlformats.org/drawingml/2006/main" xmlns:r="http://schemas.openxmlformats.org/officeDocument/2006/relationships" xmlns:p="http://schemas.openxmlformats.org/presentationml/2006/main">
   <p:cSld>
     <p:bg>
       <p:bgPr>
@@ -18062,7 +18291,14 @@
         <p:cNvGrpSpPr/>
         <p:nvPr/>
       </p:nvGrpSpPr>
-      <p:grpSpPr/>
+      <p:grpSpPr>
+        <a:xfrm>
+          <a:off x="0" y="0"/>
+          <a:ext cx="0" cy="0"/>
+          <a:chOff x="0" y="0"/>
+          <a:chExt cx="0" cy="0"/>
+        </a:xfrm>
+      </p:grpSpPr>
       <p:sp>
         <p:nvSpPr>
           <p:cNvPr id="2" name="TextBox 1"/>
@@ -18185,6 +18421,7 @@
           <a:lstStyle/>
           <a:p>
             <a:pPr algn="ctr"/>
+            <a:endParaRPr/>
           </a:p>
         </p:txBody>
       </p:sp>
@@ -18515,6 +18752,7 @@
           <a:lstStyle/>
           <a:p>
             <a:pPr algn="ctr"/>
+            <a:endParaRPr/>
           </a:p>
         </p:txBody>
       </p:sp>
@@ -18845,6 +19083,7 @@
           <a:lstStyle/>
           <a:p>
             <a:pPr algn="ctr"/>
+            <a:endParaRPr/>
           </a:p>
         </p:txBody>
       </p:sp>
@@ -19175,6 +19414,7 @@
           <a:lstStyle/>
           <a:p>
             <a:pPr algn="ctr"/>
+            <a:endParaRPr/>
           </a:p>
         </p:txBody>
       </p:sp>
@@ -19505,6 +19745,7 @@
           <a:lstStyle/>
           <a:p>
             <a:pPr algn="ctr"/>
+            <a:endParaRPr/>
           </a:p>
         </p:txBody>
       </p:sp>
@@ -19835,6 +20076,7 @@
           <a:lstStyle/>
           <a:p>
             <a:pPr algn="ctr"/>
+            <a:endParaRPr/>
           </a:p>
         </p:txBody>
       </p:sp>
@@ -20165,6 +20407,7 @@
           <a:lstStyle/>
           <a:p>
             <a:pPr algn="ctr"/>
+            <a:endParaRPr/>
           </a:p>
         </p:txBody>
       </p:sp>

</xml_diff>

<commit_message>
fix(g8-e): close incident audit cleanup
</commit_message>
<xml_diff>
--- a/deliverables/review-1/semantic-communication-first-review.pptx
+++ b/deliverables/review-1/semantic-communication-first-review.pptx
@@ -5,20 +5,20 @@
     <p:sldMasterId id="2147483648" r:id="rId1"/>
   </p:sldMasterIdLst>
   <p:sldIdLst>
-    <p:sldId id="256" r:id="rId2"/>
-    <p:sldId id="257" r:id="rId3"/>
-    <p:sldId id="258" r:id="rId4"/>
-    <p:sldId id="259" r:id="rId5"/>
-    <p:sldId id="260" r:id="rId6"/>
-    <p:sldId id="261" r:id="rId7"/>
-    <p:sldId id="262" r:id="rId8"/>
-    <p:sldId id="263" r:id="rId9"/>
-    <p:sldId id="264" r:id="rId10"/>
-    <p:sldId id="265" r:id="rId11"/>
-    <p:sldId id="266" r:id="rId12"/>
-    <p:sldId id="267" r:id="rId13"/>
+    <p:sldId id="256" r:id="rId7"/>
+    <p:sldId id="257" r:id="rId8"/>
+    <p:sldId id="258" r:id="rId9"/>
+    <p:sldId id="259" r:id="rId10"/>
+    <p:sldId id="260" r:id="rId11"/>
+    <p:sldId id="261" r:id="rId12"/>
+    <p:sldId id="262" r:id="rId13"/>
+    <p:sldId id="263" r:id="rId14"/>
+    <p:sldId id="264" r:id="rId15"/>
+    <p:sldId id="265" r:id="rId16"/>
+    <p:sldId id="266" r:id="rId17"/>
+    <p:sldId id="267" r:id="rId18"/>
   </p:sldIdLst>
-  <p:sldSz cx="12192000" cy="6858000"/>
+  <p:sldSz cx="12191695" cy="6858000" type="screen4x3"/>
   <p:notesSz cx="6858000" cy="9144000"/>
   <p:defaultTextStyle>
     <a:defPPr>
@@ -115,22 +115,6 @@
       </a:defRPr>
     </a:lvl9pPr>
   </p:defaultTextStyle>
-  <p:extLst>
-    <p:ext uri="{EFAFB233-063F-42B5-8137-9DF3F51BA10A}">
-      <p15:sldGuideLst xmlns:p15="http://schemas.microsoft.com/office/powerpoint/2012/main">
-        <p15:guide id="1" orient="horz" pos="2160">
-          <p15:clr>
-            <a:srgbClr val="A4A3A4"/>
-          </p15:clr>
-        </p15:guide>
-        <p15:guide id="2" pos="2880">
-          <p15:clr>
-            <a:srgbClr val="A4A3A4"/>
-          </p15:clr>
-        </p15:guide>
-      </p15:sldGuideLst>
-    </p:ext>
-  </p:extLst>
 </p:presentation>
 </file>
 
@@ -172,9 +156,10 @@
           <a:lstStyle/>
           <a:p>
             <a:r>
-              <a:rPr lang="en-US"/>
+              <a:rPr lang="en-US" smtClean="0"/>
               <a:t>Click to edit Master title style</a:t>
             </a:r>
+            <a:endParaRPr lang="en-US"/>
           </a:p>
         </p:txBody>
       </p:sp>
@@ -290,9 +275,10 @@
           </a:lstStyle>
           <a:p>
             <a:r>
-              <a:rPr lang="en-US"/>
+              <a:rPr lang="en-US" smtClean="0"/>
               <a:t>Click to edit Master subtitle style</a:t>
             </a:r>
+            <a:endParaRPr lang="en-US"/>
           </a:p>
         </p:txBody>
       </p:sp>
@@ -313,7 +299,7 @@
           <a:p>
             <a:fld id="{5BCAD085-E8A6-8845-BD4E-CB4CCA059FC4}" type="datetimeFigureOut">
               <a:rPr lang="en-US" smtClean="0"/>
-              <a:t>8/21/2026</a:t>
+              <a:t>1/27/13</a:t>
             </a:fld>
             <a:endParaRPr lang="en-US"/>
           </a:p>
@@ -407,9 +393,10 @@
           <a:lstStyle/>
           <a:p>
             <a:r>
-              <a:rPr lang="en-US"/>
+              <a:rPr lang="en-US" smtClean="0"/>
               <a:t>Click to edit Master title style</a:t>
             </a:r>
+            <a:endParaRPr lang="en-US"/>
           </a:p>
         </p:txBody>
       </p:sp>
@@ -430,37 +417,38 @@
           <a:p>
             <a:pPr lvl="0"/>
             <a:r>
-              <a:rPr lang="en-US"/>
+              <a:rPr lang="en-US" smtClean="0"/>
               <a:t>Click to edit Master text styles</a:t>
             </a:r>
           </a:p>
           <a:p>
             <a:pPr lvl="1"/>
             <a:r>
-              <a:rPr lang="en-US"/>
+              <a:rPr lang="en-US" smtClean="0"/>
               <a:t>Second level</a:t>
             </a:r>
           </a:p>
           <a:p>
             <a:pPr lvl="2"/>
             <a:r>
-              <a:rPr lang="en-US"/>
+              <a:rPr lang="en-US" smtClean="0"/>
               <a:t>Third level</a:t>
             </a:r>
           </a:p>
           <a:p>
             <a:pPr lvl="3"/>
             <a:r>
-              <a:rPr lang="en-US"/>
+              <a:rPr lang="en-US" smtClean="0"/>
               <a:t>Fourth level</a:t>
             </a:r>
           </a:p>
           <a:p>
             <a:pPr lvl="4"/>
             <a:r>
-              <a:rPr lang="en-US"/>
+              <a:rPr lang="en-US" smtClean="0"/>
               <a:t>Fifth level</a:t>
             </a:r>
+            <a:endParaRPr lang="en-US"/>
           </a:p>
         </p:txBody>
       </p:sp>
@@ -481,7 +469,7 @@
           <a:p>
             <a:fld id="{5BCAD085-E8A6-8845-BD4E-CB4CCA059FC4}" type="datetimeFigureOut">
               <a:rPr lang="en-US" smtClean="0"/>
-              <a:t>8/21/2026</a:t>
+              <a:t>1/27/13</a:t>
             </a:fld>
             <a:endParaRPr lang="en-US"/>
           </a:p>
@@ -580,9 +568,10 @@
           <a:lstStyle/>
           <a:p>
             <a:r>
-              <a:rPr lang="en-US"/>
+              <a:rPr lang="en-US" smtClean="0"/>
               <a:t>Click to edit Master title style</a:t>
             </a:r>
+            <a:endParaRPr lang="en-US"/>
           </a:p>
         </p:txBody>
       </p:sp>
@@ -608,37 +597,38 @@
           <a:p>
             <a:pPr lvl="0"/>
             <a:r>
-              <a:rPr lang="en-US"/>
+              <a:rPr lang="en-US" smtClean="0"/>
               <a:t>Click to edit Master text styles</a:t>
             </a:r>
           </a:p>
           <a:p>
             <a:pPr lvl="1"/>
             <a:r>
-              <a:rPr lang="en-US"/>
+              <a:rPr lang="en-US" smtClean="0"/>
               <a:t>Second level</a:t>
             </a:r>
           </a:p>
           <a:p>
             <a:pPr lvl="2"/>
             <a:r>
-              <a:rPr lang="en-US"/>
+              <a:rPr lang="en-US" smtClean="0"/>
               <a:t>Third level</a:t>
             </a:r>
           </a:p>
           <a:p>
             <a:pPr lvl="3"/>
             <a:r>
-              <a:rPr lang="en-US"/>
+              <a:rPr lang="en-US" smtClean="0"/>
               <a:t>Fourth level</a:t>
             </a:r>
           </a:p>
           <a:p>
             <a:pPr lvl="4"/>
             <a:r>
-              <a:rPr lang="en-US"/>
+              <a:rPr lang="en-US" smtClean="0"/>
               <a:t>Fifth level</a:t>
             </a:r>
+            <a:endParaRPr lang="en-US"/>
           </a:p>
         </p:txBody>
       </p:sp>
@@ -659,7 +649,7 @@
           <a:p>
             <a:fld id="{5BCAD085-E8A6-8845-BD4E-CB4CCA059FC4}" type="datetimeFigureOut">
               <a:rPr lang="en-US" smtClean="0"/>
-              <a:t>8/21/2026</a:t>
+              <a:t>1/27/13</a:t>
             </a:fld>
             <a:endParaRPr lang="en-US"/>
           </a:p>
@@ -753,9 +743,10 @@
           <a:lstStyle/>
           <a:p>
             <a:r>
-              <a:rPr lang="en-US"/>
+              <a:rPr lang="en-US" smtClean="0"/>
               <a:t>Click to edit Master title style</a:t>
             </a:r>
+            <a:endParaRPr lang="en-US"/>
           </a:p>
         </p:txBody>
       </p:sp>
@@ -776,37 +767,38 @@
           <a:p>
             <a:pPr lvl="0"/>
             <a:r>
-              <a:rPr lang="en-US"/>
+              <a:rPr lang="en-US" smtClean="0"/>
               <a:t>Click to edit Master text styles</a:t>
             </a:r>
           </a:p>
           <a:p>
             <a:pPr lvl="1"/>
             <a:r>
-              <a:rPr lang="en-US"/>
+              <a:rPr lang="en-US" smtClean="0"/>
               <a:t>Second level</a:t>
             </a:r>
           </a:p>
           <a:p>
             <a:pPr lvl="2"/>
             <a:r>
-              <a:rPr lang="en-US"/>
+              <a:rPr lang="en-US" smtClean="0"/>
               <a:t>Third level</a:t>
             </a:r>
           </a:p>
           <a:p>
             <a:pPr lvl="3"/>
             <a:r>
-              <a:rPr lang="en-US"/>
+              <a:rPr lang="en-US" smtClean="0"/>
               <a:t>Fourth level</a:t>
             </a:r>
           </a:p>
           <a:p>
             <a:pPr lvl="4"/>
             <a:r>
-              <a:rPr lang="en-US"/>
+              <a:rPr lang="en-US" smtClean="0"/>
               <a:t>Fifth level</a:t>
             </a:r>
+            <a:endParaRPr lang="en-US"/>
           </a:p>
         </p:txBody>
       </p:sp>
@@ -827,7 +819,7 @@
           <a:p>
             <a:fld id="{5BCAD085-E8A6-8845-BD4E-CB4CCA059FC4}" type="datetimeFigureOut">
               <a:rPr lang="en-US" smtClean="0"/>
-              <a:t>8/21/2026</a:t>
+              <a:t>1/27/13</a:t>
             </a:fld>
             <a:endParaRPr lang="en-US"/>
           </a:p>
@@ -930,9 +922,10 @@
           </a:lstStyle>
           <a:p>
             <a:r>
-              <a:rPr lang="en-US"/>
+              <a:rPr lang="en-US" smtClean="0"/>
               <a:t>Click to edit Master title style</a:t>
             </a:r>
+            <a:endParaRPr lang="en-US"/>
           </a:p>
         </p:txBody>
       </p:sp>
@@ -1049,7 +1042,7 @@
           <a:p>
             <a:pPr lvl="0"/>
             <a:r>
-              <a:rPr lang="en-US"/>
+              <a:rPr lang="en-US" smtClean="0"/>
               <a:t>Click to edit Master text styles</a:t>
             </a:r>
           </a:p>
@@ -1072,7 +1065,7 @@
           <a:p>
             <a:fld id="{5BCAD085-E8A6-8845-BD4E-CB4CCA059FC4}" type="datetimeFigureOut">
               <a:rPr lang="en-US" smtClean="0"/>
-              <a:t>8/21/2026</a:t>
+              <a:t>1/27/13</a:t>
             </a:fld>
             <a:endParaRPr lang="en-US"/>
           </a:p>
@@ -1166,9 +1159,10 @@
           <a:lstStyle/>
           <a:p>
             <a:r>
-              <a:rPr lang="en-US"/>
+              <a:rPr lang="en-US" smtClean="0"/>
               <a:t>Click to edit Master title style</a:t>
             </a:r>
+            <a:endParaRPr lang="en-US"/>
           </a:p>
         </p:txBody>
       </p:sp>
@@ -1222,37 +1216,38 @@
           <a:p>
             <a:pPr lvl="0"/>
             <a:r>
-              <a:rPr lang="en-US"/>
+              <a:rPr lang="en-US" smtClean="0"/>
               <a:t>Click to edit Master text styles</a:t>
             </a:r>
           </a:p>
           <a:p>
             <a:pPr lvl="1"/>
             <a:r>
-              <a:rPr lang="en-US"/>
+              <a:rPr lang="en-US" smtClean="0"/>
               <a:t>Second level</a:t>
             </a:r>
           </a:p>
           <a:p>
             <a:pPr lvl="2"/>
             <a:r>
-              <a:rPr lang="en-US"/>
+              <a:rPr lang="en-US" smtClean="0"/>
               <a:t>Third level</a:t>
             </a:r>
           </a:p>
           <a:p>
             <a:pPr lvl="3"/>
             <a:r>
-              <a:rPr lang="en-US"/>
+              <a:rPr lang="en-US" smtClean="0"/>
               <a:t>Fourth level</a:t>
             </a:r>
           </a:p>
           <a:p>
             <a:pPr lvl="4"/>
             <a:r>
-              <a:rPr lang="en-US"/>
+              <a:rPr lang="en-US" smtClean="0"/>
               <a:t>Fifth level</a:t>
             </a:r>
+            <a:endParaRPr lang="en-US"/>
           </a:p>
         </p:txBody>
       </p:sp>
@@ -1306,37 +1301,38 @@
           <a:p>
             <a:pPr lvl="0"/>
             <a:r>
-              <a:rPr lang="en-US"/>
+              <a:rPr lang="en-US" smtClean="0"/>
               <a:t>Click to edit Master text styles</a:t>
             </a:r>
           </a:p>
           <a:p>
             <a:pPr lvl="1"/>
             <a:r>
-              <a:rPr lang="en-US"/>
+              <a:rPr lang="en-US" smtClean="0"/>
               <a:t>Second level</a:t>
             </a:r>
           </a:p>
           <a:p>
             <a:pPr lvl="2"/>
             <a:r>
-              <a:rPr lang="en-US"/>
+              <a:rPr lang="en-US" smtClean="0"/>
               <a:t>Third level</a:t>
             </a:r>
           </a:p>
           <a:p>
             <a:pPr lvl="3"/>
             <a:r>
-              <a:rPr lang="en-US"/>
+              <a:rPr lang="en-US" smtClean="0"/>
               <a:t>Fourth level</a:t>
             </a:r>
           </a:p>
           <a:p>
             <a:pPr lvl="4"/>
             <a:r>
-              <a:rPr lang="en-US"/>
+              <a:rPr lang="en-US" smtClean="0"/>
               <a:t>Fifth level</a:t>
             </a:r>
+            <a:endParaRPr lang="en-US"/>
           </a:p>
         </p:txBody>
       </p:sp>
@@ -1357,7 +1353,7 @@
           <a:p>
             <a:fld id="{5BCAD085-E8A6-8845-BD4E-CB4CCA059FC4}" type="datetimeFigureOut">
               <a:rPr lang="en-US" smtClean="0"/>
-              <a:t>8/21/2026</a:t>
+              <a:t>1/27/13</a:t>
             </a:fld>
             <a:endParaRPr lang="en-US"/>
           </a:p>
@@ -1455,9 +1451,10 @@
           </a:lstStyle>
           <a:p>
             <a:r>
-              <a:rPr lang="en-US"/>
+              <a:rPr lang="en-US" smtClean="0"/>
               <a:t>Click to edit Master title style</a:t>
             </a:r>
+            <a:endParaRPr lang="en-US"/>
           </a:p>
         </p:txBody>
       </p:sp>
@@ -1520,7 +1517,7 @@
           <a:p>
             <a:pPr lvl="0"/>
             <a:r>
-              <a:rPr lang="en-US"/>
+              <a:rPr lang="en-US" smtClean="0"/>
               <a:t>Click to edit Master text styles</a:t>
             </a:r>
           </a:p>
@@ -1576,37 +1573,38 @@
           <a:p>
             <a:pPr lvl="0"/>
             <a:r>
-              <a:rPr lang="en-US"/>
+              <a:rPr lang="en-US" smtClean="0"/>
               <a:t>Click to edit Master text styles</a:t>
             </a:r>
           </a:p>
           <a:p>
             <a:pPr lvl="1"/>
             <a:r>
-              <a:rPr lang="en-US"/>
+              <a:rPr lang="en-US" smtClean="0"/>
               <a:t>Second level</a:t>
             </a:r>
           </a:p>
           <a:p>
             <a:pPr lvl="2"/>
             <a:r>
-              <a:rPr lang="en-US"/>
+              <a:rPr lang="en-US" smtClean="0"/>
               <a:t>Third level</a:t>
             </a:r>
           </a:p>
           <a:p>
             <a:pPr lvl="3"/>
             <a:r>
-              <a:rPr lang="en-US"/>
+              <a:rPr lang="en-US" smtClean="0"/>
               <a:t>Fourth level</a:t>
             </a:r>
           </a:p>
           <a:p>
             <a:pPr lvl="4"/>
             <a:r>
-              <a:rPr lang="en-US"/>
+              <a:rPr lang="en-US" smtClean="0"/>
               <a:t>Fifth level</a:t>
             </a:r>
+            <a:endParaRPr lang="en-US"/>
           </a:p>
         </p:txBody>
       </p:sp>
@@ -1669,7 +1667,7 @@
           <a:p>
             <a:pPr lvl="0"/>
             <a:r>
-              <a:rPr lang="en-US"/>
+              <a:rPr lang="en-US" smtClean="0"/>
               <a:t>Click to edit Master text styles</a:t>
             </a:r>
           </a:p>
@@ -1725,37 +1723,38 @@
           <a:p>
             <a:pPr lvl="0"/>
             <a:r>
-              <a:rPr lang="en-US"/>
+              <a:rPr lang="en-US" smtClean="0"/>
               <a:t>Click to edit Master text styles</a:t>
             </a:r>
           </a:p>
           <a:p>
             <a:pPr lvl="1"/>
             <a:r>
-              <a:rPr lang="en-US"/>
+              <a:rPr lang="en-US" smtClean="0"/>
               <a:t>Second level</a:t>
             </a:r>
           </a:p>
           <a:p>
             <a:pPr lvl="2"/>
             <a:r>
-              <a:rPr lang="en-US"/>
+              <a:rPr lang="en-US" smtClean="0"/>
               <a:t>Third level</a:t>
             </a:r>
           </a:p>
           <a:p>
             <a:pPr lvl="3"/>
             <a:r>
-              <a:rPr lang="en-US"/>
+              <a:rPr lang="en-US" smtClean="0"/>
               <a:t>Fourth level</a:t>
             </a:r>
           </a:p>
           <a:p>
             <a:pPr lvl="4"/>
             <a:r>
-              <a:rPr lang="en-US"/>
+              <a:rPr lang="en-US" smtClean="0"/>
               <a:t>Fifth level</a:t>
             </a:r>
+            <a:endParaRPr lang="en-US"/>
           </a:p>
         </p:txBody>
       </p:sp>
@@ -1776,7 +1775,7 @@
           <a:p>
             <a:fld id="{5BCAD085-E8A6-8845-BD4E-CB4CCA059FC4}" type="datetimeFigureOut">
               <a:rPr lang="en-US" smtClean="0"/>
-              <a:t>8/21/2026</a:t>
+              <a:t>1/27/13</a:t>
             </a:fld>
             <a:endParaRPr lang="en-US"/>
           </a:p>
@@ -1870,9 +1869,10 @@
           <a:lstStyle/>
           <a:p>
             <a:r>
-              <a:rPr lang="en-US"/>
+              <a:rPr lang="en-US" smtClean="0"/>
               <a:t>Click to edit Master title style</a:t>
             </a:r>
+            <a:endParaRPr lang="en-US"/>
           </a:p>
         </p:txBody>
       </p:sp>
@@ -1893,7 +1893,7 @@
           <a:p>
             <a:fld id="{5BCAD085-E8A6-8845-BD4E-CB4CCA059FC4}" type="datetimeFigureOut">
               <a:rPr lang="en-US" smtClean="0"/>
-              <a:t>8/21/2026</a:t>
+              <a:t>1/27/13</a:t>
             </a:fld>
             <a:endParaRPr lang="en-US"/>
           </a:p>
@@ -1988,7 +1988,7 @@
           <a:p>
             <a:fld id="{5BCAD085-E8A6-8845-BD4E-CB4CCA059FC4}" type="datetimeFigureOut">
               <a:rPr lang="en-US" smtClean="0"/>
-              <a:t>8/21/2026</a:t>
+              <a:t>1/27/13</a:t>
             </a:fld>
             <a:endParaRPr lang="en-US"/>
           </a:p>
@@ -2091,9 +2091,10 @@
           </a:lstStyle>
           <a:p>
             <a:r>
-              <a:rPr lang="en-US"/>
+              <a:rPr lang="en-US" smtClean="0"/>
               <a:t>Click to edit Master title style</a:t>
             </a:r>
+            <a:endParaRPr lang="en-US"/>
           </a:p>
         </p:txBody>
       </p:sp>
@@ -2147,37 +2148,38 @@
           <a:p>
             <a:pPr lvl="0"/>
             <a:r>
-              <a:rPr lang="en-US"/>
+              <a:rPr lang="en-US" smtClean="0"/>
               <a:t>Click to edit Master text styles</a:t>
             </a:r>
           </a:p>
           <a:p>
             <a:pPr lvl="1"/>
             <a:r>
-              <a:rPr lang="en-US"/>
+              <a:rPr lang="en-US" smtClean="0"/>
               <a:t>Second level</a:t>
             </a:r>
           </a:p>
           <a:p>
             <a:pPr lvl="2"/>
             <a:r>
-              <a:rPr lang="en-US"/>
+              <a:rPr lang="en-US" smtClean="0"/>
               <a:t>Third level</a:t>
             </a:r>
           </a:p>
           <a:p>
             <a:pPr lvl="3"/>
             <a:r>
-              <a:rPr lang="en-US"/>
+              <a:rPr lang="en-US" smtClean="0"/>
               <a:t>Fourth level</a:t>
             </a:r>
           </a:p>
           <a:p>
             <a:pPr lvl="4"/>
             <a:r>
-              <a:rPr lang="en-US"/>
+              <a:rPr lang="en-US" smtClean="0"/>
               <a:t>Fifth level</a:t>
             </a:r>
+            <a:endParaRPr lang="en-US"/>
           </a:p>
         </p:txBody>
       </p:sp>
@@ -2240,7 +2242,7 @@
           <a:p>
             <a:pPr lvl="0"/>
             <a:r>
-              <a:rPr lang="en-US"/>
+              <a:rPr lang="en-US" smtClean="0"/>
               <a:t>Click to edit Master text styles</a:t>
             </a:r>
           </a:p>
@@ -2263,7 +2265,7 @@
           <a:p>
             <a:fld id="{5BCAD085-E8A6-8845-BD4E-CB4CCA059FC4}" type="datetimeFigureOut">
               <a:rPr lang="en-US" smtClean="0"/>
-              <a:t>8/21/2026</a:t>
+              <a:t>1/27/13</a:t>
             </a:fld>
             <a:endParaRPr lang="en-US"/>
           </a:p>
@@ -2366,9 +2368,10 @@
           </a:lstStyle>
           <a:p>
             <a:r>
-              <a:rPr lang="en-US"/>
+              <a:rPr lang="en-US" smtClean="0"/>
               <a:t>Click to edit Master title style</a:t>
             </a:r>
+            <a:endParaRPr lang="en-US"/>
           </a:p>
         </p:txBody>
       </p:sp>
@@ -2492,7 +2495,7 @@
           <a:p>
             <a:pPr lvl="0"/>
             <a:r>
-              <a:rPr lang="en-US"/>
+              <a:rPr lang="en-US" smtClean="0"/>
               <a:t>Click to edit Master text styles</a:t>
             </a:r>
           </a:p>
@@ -2515,7 +2518,7 @@
           <a:p>
             <a:fld id="{5BCAD085-E8A6-8845-BD4E-CB4CCA059FC4}" type="datetimeFigureOut">
               <a:rPr lang="en-US" smtClean="0"/>
-              <a:t>8/21/2026</a:t>
+              <a:t>1/27/13</a:t>
             </a:fld>
             <a:endParaRPr lang="en-US"/>
           </a:p>
@@ -2624,9 +2627,10 @@
           <a:lstStyle/>
           <a:p>
             <a:r>
-              <a:rPr lang="en-US"/>
+              <a:rPr lang="en-US" smtClean="0"/>
               <a:t>Click to edit Master title style</a:t>
             </a:r>
+            <a:endParaRPr lang="en-US"/>
           </a:p>
         </p:txBody>
       </p:sp>
@@ -2657,37 +2661,38 @@
           <a:p>
             <a:pPr lvl="0"/>
             <a:r>
-              <a:rPr lang="en-US"/>
+              <a:rPr lang="en-US" smtClean="0"/>
               <a:t>Click to edit Master text styles</a:t>
             </a:r>
           </a:p>
           <a:p>
             <a:pPr lvl="1"/>
             <a:r>
-              <a:rPr lang="en-US"/>
+              <a:rPr lang="en-US" smtClean="0"/>
               <a:t>Second level</a:t>
             </a:r>
           </a:p>
           <a:p>
             <a:pPr lvl="2"/>
             <a:r>
-              <a:rPr lang="en-US"/>
+              <a:rPr lang="en-US" smtClean="0"/>
               <a:t>Third level</a:t>
             </a:r>
           </a:p>
           <a:p>
             <a:pPr lvl="3"/>
             <a:r>
-              <a:rPr lang="en-US"/>
+              <a:rPr lang="en-US" smtClean="0"/>
               <a:t>Fourth level</a:t>
             </a:r>
           </a:p>
           <a:p>
             <a:pPr lvl="4"/>
             <a:r>
-              <a:rPr lang="en-US"/>
+              <a:rPr lang="en-US" smtClean="0"/>
               <a:t>Fifth level</a:t>
             </a:r>
+            <a:endParaRPr lang="en-US"/>
           </a:p>
         </p:txBody>
       </p:sp>
@@ -2726,7 +2731,7 @@
           <a:p>
             <a:fld id="{5BCAD085-E8A6-8845-BD4E-CB4CCA059FC4}" type="datetimeFigureOut">
               <a:rPr lang="en-US" smtClean="0"/>
-              <a:t>8/21/2026</a:t>
+              <a:t>1/27/13</a:t>
             </a:fld>
             <a:endParaRPr lang="en-US"/>
           </a:p>
@@ -3085,7 +3090,7 @@
 </file>
 
 <file path=ppt/slides/slide1.xml><?xml version="1.0" encoding="utf-8"?>
-<p:sld xmlns:a="http://schemas.openxmlformats.org/drawingml/2006/main" xmlns:r="http://schemas.openxmlformats.org/officeDocument/2006/relationships" xmlns:p="http://schemas.openxmlformats.org/presentationml/2006/main">
+<p:sld xmlns:a="http://schemas.openxmlformats.org/drawingml/2006/main" xmlns:p="http://schemas.openxmlformats.org/presentationml/2006/main" xmlns:r="http://schemas.openxmlformats.org/officeDocument/2006/relationships">
   <p:cSld>
     <p:bg>
       <p:bgPr>
@@ -3101,14 +3106,7 @@
         <p:cNvGrpSpPr/>
         <p:nvPr/>
       </p:nvGrpSpPr>
-      <p:grpSpPr>
-        <a:xfrm>
-          <a:off x="0" y="0"/>
-          <a:ext cx="0" cy="0"/>
-          <a:chOff x="0" y="0"/>
-          <a:chExt cx="0" cy="0"/>
-        </a:xfrm>
-      </p:grpSpPr>
+      <p:grpSpPr/>
       <p:sp>
         <p:nvSpPr>
           <p:cNvPr id="2" name="TextBox 1"/>
@@ -3143,7 +3141,7 @@
               </a:spcAft>
             </a:pPr>
             <a:r>
-              <a:rPr sz="3400" b="1" i="0" dirty="0">
+              <a:rPr sz="3400" b="1" i="0">
                 <a:solidFill>
                   <a:srgbClr val="111111"/>
                 </a:solidFill>
@@ -3333,7 +3331,7 @@
         <p:spPr>
           <a:xfrm>
             <a:off x="694944" y="4846320"/>
-            <a:ext cx="5303520" cy="292388"/>
+            <a:ext cx="5303520" cy="274320"/>
           </a:xfrm>
           <a:prstGeom prst="rect">
             <a:avLst/>
@@ -3358,206 +3356,104 @@
               </a:spcAft>
             </a:pPr>
             <a:r>
-              <a:rPr lang="en-US" sz="1300" b="0" i="0" dirty="0">
+              <a:rPr sz="1300" b="0" i="0">
                 <a:solidFill>
                   <a:srgbClr val="555555"/>
                 </a:solidFill>
                 <a:latin typeface="Arial"/>
               </a:rPr>
-              <a:t>22</a:t>
-            </a:r>
-            <a:r>
-              <a:rPr lang="en-US" sz="1300" b="0" i="0" baseline="30000" dirty="0">
+              <a:t>Review window: 18–22 August 2026</a:t>
+            </a:r>
+          </a:p>
+        </p:txBody>
+      </p:sp>
+      <p:sp>
+        <p:nvSpPr>
+          <p:cNvPr id="8" name="TextBox 7"/>
+          <p:cNvSpPr txBox="1"/>
+          <p:nvPr/>
+        </p:nvSpPr>
+        <p:spPr>
+          <a:xfrm>
+            <a:off x="694944" y="5248656"/>
+            <a:ext cx="5303520" cy="274320"/>
+          </a:xfrm>
+          <a:prstGeom prst="rect">
+            <a:avLst/>
+          </a:prstGeom>
+          <a:noFill/>
+        </p:spPr>
+        <p:txBody>
+          <a:bodyPr wrap="square" lIns="45720" rIns="45720" anchor="t">
+            <a:spAutoFit/>
+          </a:bodyPr>
+          <a:lstStyle/>
+          <a:p>
+            <a:pPr algn="l">
+              <a:lnSpc>
+                <a:spcPct val="100000"/>
+              </a:lnSpc>
+              <a:spcBef>
+                <a:spcPts val="0"/>
+              </a:spcBef>
+              <a:spcAft>
+                <a:spcPts val="0"/>
+              </a:spcAft>
+            </a:pPr>
+            <a:r>
+              <a:rPr sz="1300" b="0" i="0">
                 <a:solidFill>
                   <a:srgbClr val="555555"/>
                 </a:solidFill>
                 <a:latin typeface="Arial"/>
               </a:rPr>
-              <a:t>nd</a:t>
-            </a:r>
-            <a:r>
-              <a:rPr lang="en-US" sz="1300" b="0" i="0" dirty="0">
+              <a:t>Presentation slot: 15 minutes</a:t>
+            </a:r>
+          </a:p>
+        </p:txBody>
+      </p:sp>
+      <p:sp>
+        <p:nvSpPr>
+          <p:cNvPr id="9" name="TextBox 8"/>
+          <p:cNvSpPr txBox="1"/>
+          <p:nvPr/>
+        </p:nvSpPr>
+        <p:spPr>
+          <a:xfrm>
+            <a:off x="7406640" y="5230368"/>
+            <a:ext cx="3749039" cy="329184"/>
+          </a:xfrm>
+          <a:prstGeom prst="rect">
+            <a:avLst/>
+          </a:prstGeom>
+          <a:noFill/>
+        </p:spPr>
+        <p:txBody>
+          <a:bodyPr wrap="square" lIns="45720" rIns="45720" anchor="t">
+            <a:spAutoFit/>
+          </a:bodyPr>
+          <a:lstStyle/>
+          <a:p>
+            <a:pPr algn="r">
+              <a:lnSpc>
+                <a:spcPct val="100000"/>
+              </a:lnSpc>
+              <a:spcBef>
+                <a:spcPts val="0"/>
+              </a:spcBef>
+              <a:spcAft>
+                <a:spcPts val="0"/>
+              </a:spcAft>
+            </a:pPr>
+            <a:r>
+              <a:rPr sz="1100" b="0" i="0">
                 <a:solidFill>
                   <a:srgbClr val="555555"/>
                 </a:solidFill>
                 <a:latin typeface="Arial"/>
               </a:rPr>
-              <a:t> August 2026</a:t>
-            </a:r>
-            <a:endParaRPr sz="1300" b="0" i="0" dirty="0">
-              <a:solidFill>
-                <a:srgbClr val="555555"/>
-              </a:solidFill>
-              <a:latin typeface="Arial"/>
-            </a:endParaRPr>
-          </a:p>
-        </p:txBody>
-      </p:sp>
-      <p:sp>
-        <p:nvSpPr>
-          <p:cNvPr id="8" name="TextBox 7"/>
-          <p:cNvSpPr txBox="1"/>
-          <p:nvPr/>
-        </p:nvSpPr>
-        <p:spPr>
-          <a:xfrm>
-            <a:off x="694944" y="5248657"/>
-            <a:ext cx="5303520" cy="292388"/>
-          </a:xfrm>
-          <a:prstGeom prst="rect">
-            <a:avLst/>
-          </a:prstGeom>
-          <a:noFill/>
-        </p:spPr>
-        <p:txBody>
-          <a:bodyPr wrap="square" lIns="45720" rIns="45720" anchor="t">
-            <a:spAutoFit/>
-          </a:bodyPr>
-          <a:lstStyle/>
-          <a:p>
-            <a:pPr algn="l">
-              <a:lnSpc>
-                <a:spcPct val="100000"/>
-              </a:lnSpc>
-              <a:spcBef>
-                <a:spcPts val="0"/>
-              </a:spcBef>
-              <a:spcAft>
-                <a:spcPts val="0"/>
-              </a:spcAft>
-            </a:pPr>
-            <a:r>
-              <a:rPr lang="en-US" sz="1300" b="0" i="0" dirty="0">
-                <a:solidFill>
-                  <a:srgbClr val="555555"/>
-                </a:solidFill>
-                <a:latin typeface="Arial"/>
-              </a:rPr>
-              <a:t>Guide: Dr. Udit Narayana Kar</a:t>
-            </a:r>
-            <a:endParaRPr sz="1300" b="0" i="0" dirty="0">
-              <a:solidFill>
-                <a:srgbClr val="555555"/>
-              </a:solidFill>
-              <a:latin typeface="Arial"/>
-            </a:endParaRPr>
-          </a:p>
-        </p:txBody>
-      </p:sp>
-      <p:sp>
-        <p:nvSpPr>
-          <p:cNvPr id="9" name="TextBox 8"/>
-          <p:cNvSpPr txBox="1"/>
-          <p:nvPr/>
-        </p:nvSpPr>
-        <p:spPr>
-          <a:xfrm>
-            <a:off x="7406640" y="5230368"/>
-            <a:ext cx="3749039" cy="769441"/>
-          </a:xfrm>
-          <a:prstGeom prst="rect">
-            <a:avLst/>
-          </a:prstGeom>
-          <a:noFill/>
-        </p:spPr>
-        <p:txBody>
-          <a:bodyPr wrap="square" lIns="45720" rIns="45720" anchor="t">
-            <a:spAutoFit/>
-          </a:bodyPr>
-          <a:lstStyle/>
-          <a:p>
-            <a:pPr algn="r">
-              <a:lnSpc>
-                <a:spcPct val="100000"/>
-              </a:lnSpc>
-              <a:spcBef>
-                <a:spcPts val="0"/>
-              </a:spcBef>
-              <a:spcAft>
-                <a:spcPts val="0"/>
-              </a:spcAft>
-            </a:pPr>
-            <a:r>
-              <a:rPr lang="en-US" sz="1100" b="0" i="0" dirty="0">
-                <a:solidFill>
-                  <a:srgbClr val="555555"/>
-                </a:solidFill>
-                <a:latin typeface="Arial"/>
-              </a:rPr>
-              <a:t>Nishchal Ravi</a:t>
-            </a:r>
-          </a:p>
-          <a:p>
-            <a:pPr algn="r">
-              <a:lnSpc>
-                <a:spcPct val="100000"/>
-              </a:lnSpc>
-              <a:spcBef>
-                <a:spcPts val="0"/>
-              </a:spcBef>
-              <a:spcAft>
-                <a:spcPts val="0"/>
-              </a:spcAft>
-            </a:pPr>
-            <a:r>
-              <a:rPr lang="en-US" sz="1100" b="0" i="0" dirty="0">
-                <a:solidFill>
-                  <a:srgbClr val="555555"/>
-                </a:solidFill>
-                <a:latin typeface="Arial"/>
-              </a:rPr>
-              <a:t>Tanishq Srivastava</a:t>
-            </a:r>
-          </a:p>
-          <a:p>
-            <a:pPr algn="r">
-              <a:lnSpc>
-                <a:spcPct val="100000"/>
-              </a:lnSpc>
-              <a:spcBef>
-                <a:spcPts val="0"/>
-              </a:spcBef>
-              <a:spcAft>
-                <a:spcPts val="0"/>
-              </a:spcAft>
-            </a:pPr>
-            <a:r>
-              <a:rPr lang="en-US" sz="1100" b="0" i="0" dirty="0">
-                <a:solidFill>
-                  <a:srgbClr val="555555"/>
-                </a:solidFill>
-                <a:latin typeface="Arial"/>
-              </a:rPr>
-              <a:t>Amogh Mishra</a:t>
-            </a:r>
-          </a:p>
-          <a:p>
-            <a:pPr algn="r">
-              <a:lnSpc>
-                <a:spcPct val="100000"/>
-              </a:lnSpc>
-              <a:spcBef>
-                <a:spcPts val="0"/>
-              </a:spcBef>
-              <a:spcAft>
-                <a:spcPts val="0"/>
-              </a:spcAft>
-            </a:pPr>
-            <a:r>
-              <a:rPr lang="en-US" sz="1100" dirty="0">
-                <a:solidFill>
-                  <a:srgbClr val="555555"/>
-                </a:solidFill>
-                <a:latin typeface="Arial"/>
-              </a:rPr>
-              <a:t>Sreeparna Mukherjee</a:t>
-            </a:r>
-            <a:endParaRPr sz="1100" b="0" i="0" dirty="0">
-              <a:solidFill>
-                <a:srgbClr val="555555"/>
-              </a:solidFill>
-              <a:latin typeface="Arial"/>
-            </a:endParaRPr>
+              <a:t>Team and guide details to be added</a:t>
+            </a:r>
           </a:p>
         </p:txBody>
       </p:sp>
@@ -3740,7 +3636,7 @@
 </file>
 
 <file path=ppt/slides/slide10.xml><?xml version="1.0" encoding="utf-8"?>
-<p:sld xmlns:a="http://schemas.openxmlformats.org/drawingml/2006/main" xmlns:r="http://schemas.openxmlformats.org/officeDocument/2006/relationships" xmlns:p="http://schemas.openxmlformats.org/presentationml/2006/main">
+<p:sld xmlns:a="http://schemas.openxmlformats.org/drawingml/2006/main" xmlns:p="http://schemas.openxmlformats.org/presentationml/2006/main" xmlns:r="http://schemas.openxmlformats.org/officeDocument/2006/relationships">
   <p:cSld>
     <p:bg>
       <p:bgPr>
@@ -3756,14 +3652,7 @@
         <p:cNvGrpSpPr/>
         <p:nvPr/>
       </p:nvGrpSpPr>
-      <p:grpSpPr>
-        <a:xfrm>
-          <a:off x="0" y="0"/>
-          <a:ext cx="0" cy="0"/>
-          <a:chOff x="0" y="0"/>
-          <a:chExt cx="0" cy="0"/>
-        </a:xfrm>
-      </p:grpSpPr>
+      <p:grpSpPr/>
       <p:sp>
         <p:nvSpPr>
           <p:cNvPr id="2" name="TextBox 1"/>
@@ -3931,7 +3820,6 @@
           <a:lstStyle/>
           <a:p>
             <a:pPr algn="ctr"/>
-            <a:endParaRPr/>
           </a:p>
         </p:txBody>
       </p:sp>
@@ -4057,7 +3945,6 @@
           <a:lstStyle/>
           <a:p>
             <a:pPr algn="ctr"/>
-            <a:endParaRPr/>
           </a:p>
         </p:txBody>
       </p:sp>
@@ -4183,7 +4070,6 @@
           <a:lstStyle/>
           <a:p>
             <a:pPr algn="ctr"/>
-            <a:endParaRPr/>
           </a:p>
         </p:txBody>
       </p:sp>
@@ -4309,7 +4195,6 @@
           <a:lstStyle/>
           <a:p>
             <a:pPr algn="ctr"/>
-            <a:endParaRPr/>
           </a:p>
         </p:txBody>
       </p:sp>
@@ -4550,7 +4435,6 @@
           <a:lstStyle/>
           <a:p>
             <a:pPr algn="ctr"/>
-            <a:endParaRPr/>
           </a:p>
         </p:txBody>
       </p:sp>
@@ -4676,7 +4560,6 @@
           <a:lstStyle/>
           <a:p>
             <a:pPr algn="ctr"/>
-            <a:endParaRPr/>
           </a:p>
         </p:txBody>
       </p:sp>
@@ -4802,7 +4685,6 @@
           <a:lstStyle/>
           <a:p>
             <a:pPr algn="ctr"/>
-            <a:endParaRPr/>
           </a:p>
         </p:txBody>
       </p:sp>
@@ -4928,7 +4810,6 @@
           <a:lstStyle/>
           <a:p>
             <a:pPr algn="ctr"/>
-            <a:endParaRPr/>
           </a:p>
         </p:txBody>
       </p:sp>
@@ -5054,7 +4935,6 @@
           <a:lstStyle/>
           <a:p>
             <a:pPr algn="ctr"/>
-            <a:endParaRPr/>
           </a:p>
         </p:txBody>
       </p:sp>
@@ -5180,7 +5060,6 @@
           <a:lstStyle/>
           <a:p>
             <a:pPr algn="ctr"/>
-            <a:endParaRPr/>
           </a:p>
         </p:txBody>
       </p:sp>
@@ -5351,7 +5230,6 @@
           <a:lstStyle/>
           <a:p>
             <a:pPr algn="ctr"/>
-            <a:endParaRPr/>
           </a:p>
         </p:txBody>
       </p:sp>
@@ -5522,7 +5400,6 @@
           <a:lstStyle/>
           <a:p>
             <a:pPr algn="ctr"/>
-            <a:endParaRPr/>
           </a:p>
         </p:txBody>
       </p:sp>
@@ -5693,7 +5570,6 @@
           <a:lstStyle/>
           <a:p>
             <a:pPr algn="ctr"/>
-            <a:endParaRPr/>
           </a:p>
         </p:txBody>
       </p:sp>
@@ -5817,7 +5693,6 @@
           <a:lstStyle/>
           <a:p>
             <a:pPr algn="ctr"/>
-            <a:endParaRPr/>
           </a:p>
         </p:txBody>
       </p:sp>
@@ -5896,7 +5771,6 @@
           <a:lstStyle/>
           <a:p>
             <a:pPr algn="ctr"/>
-            <a:endParaRPr/>
           </a:p>
         </p:txBody>
       </p:sp>
@@ -5975,7 +5849,6 @@
           <a:lstStyle/>
           <a:p>
             <a:pPr algn="ctr"/>
-            <a:endParaRPr/>
           </a:p>
         </p:txBody>
       </p:sp>
@@ -6054,7 +5927,6 @@
           <a:lstStyle/>
           <a:p>
             <a:pPr algn="ctr"/>
-            <a:endParaRPr/>
           </a:p>
         </p:txBody>
       </p:sp>
@@ -6098,7 +5970,6 @@
           <a:lstStyle/>
           <a:p>
             <a:pPr algn="ctr"/>
-            <a:endParaRPr/>
           </a:p>
         </p:txBody>
       </p:sp>
@@ -6416,7 +6287,7 @@
 </file>
 
 <file path=ppt/slides/slide11.xml><?xml version="1.0" encoding="utf-8"?>
-<p:sld xmlns:a="http://schemas.openxmlformats.org/drawingml/2006/main" xmlns:r="http://schemas.openxmlformats.org/officeDocument/2006/relationships" xmlns:p="http://schemas.openxmlformats.org/presentationml/2006/main">
+<p:sld xmlns:a="http://schemas.openxmlformats.org/drawingml/2006/main" xmlns:p="http://schemas.openxmlformats.org/presentationml/2006/main" xmlns:r="http://schemas.openxmlformats.org/officeDocument/2006/relationships">
   <p:cSld>
     <p:bg>
       <p:bgPr>
@@ -6432,14 +6303,7 @@
         <p:cNvGrpSpPr/>
         <p:nvPr/>
       </p:nvGrpSpPr>
-      <p:grpSpPr>
-        <a:xfrm>
-          <a:off x="0" y="0"/>
-          <a:ext cx="0" cy="0"/>
-          <a:chOff x="0" y="0"/>
-          <a:chExt cx="0" cy="0"/>
-        </a:xfrm>
-      </p:grpSpPr>
+      <p:grpSpPr/>
       <p:sp>
         <p:nvSpPr>
           <p:cNvPr id="2" name="TextBox 1"/>
@@ -6562,7 +6426,6 @@
           <a:lstStyle/>
           <a:p>
             <a:pPr algn="ctr"/>
-            <a:endParaRPr/>
           </a:p>
         </p:txBody>
       </p:sp>
@@ -6698,7 +6561,6 @@
           <a:lstStyle/>
           <a:p>
             <a:pPr algn="ctr"/>
-            <a:endParaRPr/>
           </a:p>
         </p:txBody>
       </p:sp>
@@ -6834,7 +6696,6 @@
           <a:lstStyle/>
           <a:p>
             <a:pPr algn="ctr"/>
-            <a:endParaRPr/>
           </a:p>
         </p:txBody>
       </p:sp>
@@ -7080,7 +6941,6 @@
           <a:lstStyle/>
           <a:p>
             <a:pPr algn="ctr"/>
-            <a:endParaRPr/>
           </a:p>
         </p:txBody>
       </p:sp>
@@ -7308,7 +7168,7 @@
 </file>
 
 <file path=ppt/slides/slide12.xml><?xml version="1.0" encoding="utf-8"?>
-<p:sld xmlns:a="http://schemas.openxmlformats.org/drawingml/2006/main" xmlns:r="http://schemas.openxmlformats.org/officeDocument/2006/relationships" xmlns:p="http://schemas.openxmlformats.org/presentationml/2006/main">
+<p:sld xmlns:a="http://schemas.openxmlformats.org/drawingml/2006/main" xmlns:p="http://schemas.openxmlformats.org/presentationml/2006/main" xmlns:r="http://schemas.openxmlformats.org/officeDocument/2006/relationships">
   <p:cSld>
     <p:bg>
       <p:bgPr>
@@ -7324,14 +7184,7 @@
         <p:cNvGrpSpPr/>
         <p:nvPr/>
       </p:nvGrpSpPr>
-      <p:grpSpPr>
-        <a:xfrm>
-          <a:off x="0" y="0"/>
-          <a:ext cx="0" cy="0"/>
-          <a:chOff x="0" y="0"/>
-          <a:chExt cx="0" cy="0"/>
-        </a:xfrm>
-      </p:grpSpPr>
+      <p:grpSpPr/>
       <p:sp>
         <p:nvSpPr>
           <p:cNvPr id="2" name="TextBox 1"/>
@@ -8827,7 +8680,6 @@
           <a:lstStyle/>
           <a:p>
             <a:pPr algn="ctr"/>
-            <a:endParaRPr/>
           </a:p>
         </p:txBody>
       </p:sp>
@@ -9100,7 +8952,7 @@
 </file>
 
 <file path=ppt/slides/slide2.xml><?xml version="1.0" encoding="utf-8"?>
-<p:sld xmlns:a="http://schemas.openxmlformats.org/drawingml/2006/main" xmlns:r="http://schemas.openxmlformats.org/officeDocument/2006/relationships" xmlns:p="http://schemas.openxmlformats.org/presentationml/2006/main">
+<p:sld xmlns:a="http://schemas.openxmlformats.org/drawingml/2006/main" xmlns:p="http://schemas.openxmlformats.org/presentationml/2006/main" xmlns:r="http://schemas.openxmlformats.org/officeDocument/2006/relationships">
   <p:cSld>
     <p:bg>
       <p:bgPr>
@@ -9116,14 +8968,7 @@
         <p:cNvGrpSpPr/>
         <p:nvPr/>
       </p:nvGrpSpPr>
-      <p:grpSpPr>
-        <a:xfrm>
-          <a:off x="0" y="0"/>
-          <a:ext cx="0" cy="0"/>
-          <a:chOff x="0" y="0"/>
-          <a:chExt cx="0" cy="0"/>
-        </a:xfrm>
-      </p:grpSpPr>
+      <p:grpSpPr/>
       <p:sp>
         <p:nvSpPr>
           <p:cNvPr id="2" name="TextBox 1"/>
@@ -9246,7 +9091,6 @@
           <a:lstStyle/>
           <a:p>
             <a:pPr algn="ctr"/>
-            <a:endParaRPr/>
           </a:p>
         </p:txBody>
       </p:sp>
@@ -9427,7 +9271,6 @@
           <a:lstStyle/>
           <a:p>
             <a:pPr algn="ctr"/>
-            <a:endParaRPr/>
           </a:p>
         </p:txBody>
       </p:sp>
@@ -9608,7 +9451,6 @@
           <a:lstStyle/>
           <a:p>
             <a:pPr algn="ctr"/>
-            <a:endParaRPr/>
           </a:p>
         </p:txBody>
       </p:sp>
@@ -9789,7 +9631,6 @@
           <a:lstStyle/>
           <a:p>
             <a:pPr algn="ctr"/>
-            <a:endParaRPr/>
           </a:p>
         </p:txBody>
       </p:sp>
@@ -9968,7 +9809,6 @@
           <a:lstStyle/>
           <a:p>
             <a:pPr algn="ctr"/>
-            <a:endParaRPr/>
           </a:p>
         </p:txBody>
       </p:sp>
@@ -10286,7 +10126,7 @@
 </file>
 
 <file path=ppt/slides/slide3.xml><?xml version="1.0" encoding="utf-8"?>
-<p:sld xmlns:a="http://schemas.openxmlformats.org/drawingml/2006/main" xmlns:r="http://schemas.openxmlformats.org/officeDocument/2006/relationships" xmlns:p="http://schemas.openxmlformats.org/presentationml/2006/main">
+<p:sld xmlns:a="http://schemas.openxmlformats.org/drawingml/2006/main" xmlns:p="http://schemas.openxmlformats.org/presentationml/2006/main" xmlns:r="http://schemas.openxmlformats.org/officeDocument/2006/relationships">
   <p:cSld>
     <p:bg>
       <p:bgPr>
@@ -10302,14 +10142,7 @@
         <p:cNvGrpSpPr/>
         <p:nvPr/>
       </p:nvGrpSpPr>
-      <p:grpSpPr>
-        <a:xfrm>
-          <a:off x="0" y="0"/>
-          <a:ext cx="0" cy="0"/>
-          <a:chOff x="0" y="0"/>
-          <a:chExt cx="0" cy="0"/>
-        </a:xfrm>
-      </p:grpSpPr>
+      <p:grpSpPr/>
       <p:sp>
         <p:nvSpPr>
           <p:cNvPr id="2" name="TextBox 1"/>
@@ -10432,7 +10265,6 @@
           <a:lstStyle/>
           <a:p>
             <a:pPr algn="ctr"/>
-            <a:endParaRPr/>
           </a:p>
         </p:txBody>
       </p:sp>
@@ -10568,7 +10400,6 @@
           <a:lstStyle/>
           <a:p>
             <a:pPr algn="ctr"/>
-            <a:endParaRPr/>
           </a:p>
         </p:txBody>
       </p:sp>
@@ -10704,7 +10535,6 @@
           <a:lstStyle/>
           <a:p>
             <a:pPr algn="ctr"/>
-            <a:endParaRPr/>
           </a:p>
         </p:txBody>
       </p:sp>
@@ -10840,7 +10670,6 @@
           <a:lstStyle/>
           <a:p>
             <a:pPr algn="ctr"/>
-            <a:endParaRPr/>
           </a:p>
         </p:txBody>
       </p:sp>
@@ -10976,7 +10805,6 @@
           <a:lstStyle/>
           <a:p>
             <a:pPr algn="ctr"/>
-            <a:endParaRPr/>
           </a:p>
         </p:txBody>
       </p:sp>
@@ -11145,7 +10973,6 @@
           <a:lstStyle/>
           <a:p>
             <a:pPr algn="ctr"/>
-            <a:endParaRPr/>
           </a:p>
         </p:txBody>
       </p:sp>
@@ -11224,7 +11051,6 @@
           <a:lstStyle/>
           <a:p>
             <a:pPr algn="ctr"/>
-            <a:endParaRPr/>
           </a:p>
         </p:txBody>
       </p:sp>
@@ -11303,7 +11129,6 @@
           <a:lstStyle/>
           <a:p>
             <a:pPr algn="ctr"/>
-            <a:endParaRPr/>
           </a:p>
         </p:txBody>
       </p:sp>
@@ -11382,7 +11207,6 @@
           <a:lstStyle/>
           <a:p>
             <a:pPr algn="ctr"/>
-            <a:endParaRPr/>
           </a:p>
         </p:txBody>
       </p:sp>
@@ -12005,7 +11829,7 @@
 </file>
 
 <file path=ppt/slides/slide4.xml><?xml version="1.0" encoding="utf-8"?>
-<p:sld xmlns:a="http://schemas.openxmlformats.org/drawingml/2006/main" xmlns:r="http://schemas.openxmlformats.org/officeDocument/2006/relationships" xmlns:p="http://schemas.openxmlformats.org/presentationml/2006/main">
+<p:sld xmlns:a="http://schemas.openxmlformats.org/drawingml/2006/main" xmlns:p="http://schemas.openxmlformats.org/presentationml/2006/main" xmlns:r="http://schemas.openxmlformats.org/officeDocument/2006/relationships">
   <p:cSld>
     <p:bg>
       <p:bgPr>
@@ -12021,14 +11845,7 @@
         <p:cNvGrpSpPr/>
         <p:nvPr/>
       </p:nvGrpSpPr>
-      <p:grpSpPr>
-        <a:xfrm>
-          <a:off x="0" y="0"/>
-          <a:ext cx="0" cy="0"/>
-          <a:chOff x="0" y="0"/>
-          <a:chExt cx="0" cy="0"/>
-        </a:xfrm>
-      </p:grpSpPr>
+      <p:grpSpPr/>
       <p:sp>
         <p:nvSpPr>
           <p:cNvPr id="2" name="TextBox 1"/>
@@ -12151,7 +11968,6 @@
           <a:lstStyle/>
           <a:p>
             <a:pPr algn="ctr"/>
-            <a:endParaRPr/>
           </a:p>
         </p:txBody>
       </p:sp>
@@ -12287,7 +12103,6 @@
           <a:lstStyle/>
           <a:p>
             <a:pPr algn="ctr"/>
-            <a:endParaRPr/>
           </a:p>
         </p:txBody>
       </p:sp>
@@ -12423,7 +12238,6 @@
           <a:lstStyle/>
           <a:p>
             <a:pPr algn="ctr"/>
-            <a:endParaRPr/>
           </a:p>
         </p:txBody>
       </p:sp>
@@ -12559,7 +12373,6 @@
           <a:lstStyle/>
           <a:p>
             <a:pPr algn="ctr"/>
-            <a:endParaRPr/>
           </a:p>
         </p:txBody>
       </p:sp>
@@ -12695,7 +12508,6 @@
           <a:lstStyle/>
           <a:p>
             <a:pPr algn="ctr"/>
-            <a:endParaRPr/>
           </a:p>
         </p:txBody>
       </p:sp>
@@ -12864,7 +12676,6 @@
           <a:lstStyle/>
           <a:p>
             <a:pPr algn="ctr"/>
-            <a:endParaRPr/>
           </a:p>
         </p:txBody>
       </p:sp>
@@ -12943,7 +12754,6 @@
           <a:lstStyle/>
           <a:p>
             <a:pPr algn="ctr"/>
-            <a:endParaRPr/>
           </a:p>
         </p:txBody>
       </p:sp>
@@ -13022,7 +12832,6 @@
           <a:lstStyle/>
           <a:p>
             <a:pPr algn="ctr"/>
-            <a:endParaRPr/>
           </a:p>
         </p:txBody>
       </p:sp>
@@ -13101,7 +12910,6 @@
           <a:lstStyle/>
           <a:p>
             <a:pPr algn="ctr"/>
-            <a:endParaRPr/>
           </a:p>
         </p:txBody>
       </p:sp>
@@ -13360,7 +13168,6 @@
           <a:lstStyle/>
           <a:p>
             <a:pPr algn="ctr"/>
-            <a:endParaRPr/>
           </a:p>
         </p:txBody>
       </p:sp>
@@ -13633,7 +13440,7 @@
 </file>
 
 <file path=ppt/slides/slide5.xml><?xml version="1.0" encoding="utf-8"?>
-<p:sld xmlns:a="http://schemas.openxmlformats.org/drawingml/2006/main" xmlns:r="http://schemas.openxmlformats.org/officeDocument/2006/relationships" xmlns:p="http://schemas.openxmlformats.org/presentationml/2006/main">
+<p:sld xmlns:a="http://schemas.openxmlformats.org/drawingml/2006/main" xmlns:p="http://schemas.openxmlformats.org/presentationml/2006/main" xmlns:r="http://schemas.openxmlformats.org/officeDocument/2006/relationships">
   <p:cSld>
     <p:bg>
       <p:bgPr>
@@ -13649,14 +13456,7 @@
         <p:cNvGrpSpPr/>
         <p:nvPr/>
       </p:nvGrpSpPr>
-      <p:grpSpPr>
-        <a:xfrm>
-          <a:off x="0" y="0"/>
-          <a:ext cx="0" cy="0"/>
-          <a:chOff x="0" y="0"/>
-          <a:chExt cx="0" cy="0"/>
-        </a:xfrm>
-      </p:grpSpPr>
+      <p:grpSpPr/>
       <p:sp>
         <p:nvSpPr>
           <p:cNvPr id="2" name="TextBox 1"/>
@@ -14686,7 +14486,7 @@
 </file>
 
 <file path=ppt/slides/slide6.xml><?xml version="1.0" encoding="utf-8"?>
-<p:sld xmlns:a="http://schemas.openxmlformats.org/drawingml/2006/main" xmlns:r="http://schemas.openxmlformats.org/officeDocument/2006/relationships" xmlns:p="http://schemas.openxmlformats.org/presentationml/2006/main">
+<p:sld xmlns:a="http://schemas.openxmlformats.org/drawingml/2006/main" xmlns:p="http://schemas.openxmlformats.org/presentationml/2006/main" xmlns:r="http://schemas.openxmlformats.org/officeDocument/2006/relationships">
   <p:cSld>
     <p:bg>
       <p:bgPr>
@@ -14702,14 +14502,7 @@
         <p:cNvGrpSpPr/>
         <p:nvPr/>
       </p:nvGrpSpPr>
-      <p:grpSpPr>
-        <a:xfrm>
-          <a:off x="0" y="0"/>
-          <a:ext cx="0" cy="0"/>
-          <a:chOff x="0" y="0"/>
-          <a:chExt cx="0" cy="0"/>
-        </a:xfrm>
-      </p:grpSpPr>
+      <p:grpSpPr/>
       <p:sp>
         <p:nvSpPr>
           <p:cNvPr id="2" name="TextBox 1"/>
@@ -15485,7 +15278,6 @@
           <a:lstStyle/>
           <a:p>
             <a:pPr algn="ctr"/>
-            <a:endParaRPr/>
           </a:p>
         </p:txBody>
       </p:sp>
@@ -15713,7 +15505,7 @@
 </file>
 
 <file path=ppt/slides/slide7.xml><?xml version="1.0" encoding="utf-8"?>
-<p:sld xmlns:a="http://schemas.openxmlformats.org/drawingml/2006/main" xmlns:r="http://schemas.openxmlformats.org/officeDocument/2006/relationships" xmlns:p="http://schemas.openxmlformats.org/presentationml/2006/main">
+<p:sld xmlns:a="http://schemas.openxmlformats.org/drawingml/2006/main" xmlns:p="http://schemas.openxmlformats.org/presentationml/2006/main" xmlns:r="http://schemas.openxmlformats.org/officeDocument/2006/relationships">
   <p:cSld>
     <p:bg>
       <p:bgPr>
@@ -15729,14 +15521,7 @@
         <p:cNvGrpSpPr/>
         <p:nvPr/>
       </p:nvGrpSpPr>
-      <p:grpSpPr>
-        <a:xfrm>
-          <a:off x="0" y="0"/>
-          <a:ext cx="0" cy="0"/>
-          <a:chOff x="0" y="0"/>
-          <a:chExt cx="0" cy="0"/>
-        </a:xfrm>
-      </p:grpSpPr>
+      <p:grpSpPr/>
       <p:sp>
         <p:nvSpPr>
           <p:cNvPr id="2" name="TextBox 1"/>
@@ -15857,7 +15642,6 @@
           <a:lstStyle/>
           <a:p>
             <a:pPr algn="ctr"/>
-            <a:endParaRPr/>
           </a:p>
         </p:txBody>
       </p:sp>
@@ -15948,7 +15732,6 @@
           <a:lstStyle/>
           <a:p>
             <a:pPr algn="ctr"/>
-            <a:endParaRPr/>
           </a:p>
         </p:txBody>
       </p:sp>
@@ -16199,7 +15982,6 @@
           <a:lstStyle/>
           <a:p>
             <a:pPr algn="ctr"/>
-            <a:endParaRPr/>
           </a:p>
         </p:txBody>
       </p:sp>
@@ -16450,7 +16232,6 @@
           <a:lstStyle/>
           <a:p>
             <a:pPr algn="ctr"/>
-            <a:endParaRPr/>
           </a:p>
         </p:txBody>
       </p:sp>
@@ -16701,7 +16482,6 @@
           <a:lstStyle/>
           <a:p>
             <a:pPr algn="ctr"/>
-            <a:endParaRPr/>
           </a:p>
         </p:txBody>
       </p:sp>
@@ -17040,7 +16820,6 @@
           <a:lstStyle/>
           <a:p>
             <a:pPr algn="ctr"/>
-            <a:endParaRPr/>
           </a:p>
         </p:txBody>
       </p:sp>
@@ -17268,7 +17047,7 @@
 </file>
 
 <file path=ppt/slides/slide8.xml><?xml version="1.0" encoding="utf-8"?>
-<p:sld xmlns:a="http://schemas.openxmlformats.org/drawingml/2006/main" xmlns:r="http://schemas.openxmlformats.org/officeDocument/2006/relationships" xmlns:p="http://schemas.openxmlformats.org/presentationml/2006/main">
+<p:sld xmlns:a="http://schemas.openxmlformats.org/drawingml/2006/main" xmlns:p="http://schemas.openxmlformats.org/presentationml/2006/main" xmlns:r="http://schemas.openxmlformats.org/officeDocument/2006/relationships">
   <p:cSld>
     <p:bg>
       <p:bgPr>
@@ -17284,14 +17063,7 @@
         <p:cNvGrpSpPr/>
         <p:nvPr/>
       </p:nvGrpSpPr>
-      <p:grpSpPr>
-        <a:xfrm>
-          <a:off x="0" y="0"/>
-          <a:ext cx="0" cy="0"/>
-          <a:chOff x="0" y="0"/>
-          <a:chExt cx="0" cy="0"/>
-        </a:xfrm>
-      </p:grpSpPr>
+      <p:grpSpPr/>
       <p:sp>
         <p:nvSpPr>
           <p:cNvPr id="2" name="TextBox 1"/>
@@ -18047,7 +17819,6 @@
           <a:lstStyle/>
           <a:p>
             <a:pPr algn="ctr"/>
-            <a:endParaRPr/>
           </a:p>
         </p:txBody>
       </p:sp>
@@ -18275,7 +18046,7 @@
 </file>
 
 <file path=ppt/slides/slide9.xml><?xml version="1.0" encoding="utf-8"?>
-<p:sld xmlns:a="http://schemas.openxmlformats.org/drawingml/2006/main" xmlns:r="http://schemas.openxmlformats.org/officeDocument/2006/relationships" xmlns:p="http://schemas.openxmlformats.org/presentationml/2006/main">
+<p:sld xmlns:a="http://schemas.openxmlformats.org/drawingml/2006/main" xmlns:p="http://schemas.openxmlformats.org/presentationml/2006/main" xmlns:r="http://schemas.openxmlformats.org/officeDocument/2006/relationships">
   <p:cSld>
     <p:bg>
       <p:bgPr>
@@ -18291,14 +18062,7 @@
         <p:cNvGrpSpPr/>
         <p:nvPr/>
       </p:nvGrpSpPr>
-      <p:grpSpPr>
-        <a:xfrm>
-          <a:off x="0" y="0"/>
-          <a:ext cx="0" cy="0"/>
-          <a:chOff x="0" y="0"/>
-          <a:chExt cx="0" cy="0"/>
-        </a:xfrm>
-      </p:grpSpPr>
+      <p:grpSpPr/>
       <p:sp>
         <p:nvSpPr>
           <p:cNvPr id="2" name="TextBox 1"/>
@@ -18421,7 +18185,6 @@
           <a:lstStyle/>
           <a:p>
             <a:pPr algn="ctr"/>
-            <a:endParaRPr/>
           </a:p>
         </p:txBody>
       </p:sp>
@@ -18752,7 +18515,6 @@
           <a:lstStyle/>
           <a:p>
             <a:pPr algn="ctr"/>
-            <a:endParaRPr/>
           </a:p>
         </p:txBody>
       </p:sp>
@@ -19083,7 +18845,6 @@
           <a:lstStyle/>
           <a:p>
             <a:pPr algn="ctr"/>
-            <a:endParaRPr/>
           </a:p>
         </p:txBody>
       </p:sp>
@@ -19414,7 +19175,6 @@
           <a:lstStyle/>
           <a:p>
             <a:pPr algn="ctr"/>
-            <a:endParaRPr/>
           </a:p>
         </p:txBody>
       </p:sp>
@@ -19745,7 +19505,6 @@
           <a:lstStyle/>
           <a:p>
             <a:pPr algn="ctr"/>
-            <a:endParaRPr/>
           </a:p>
         </p:txBody>
       </p:sp>
@@ -20076,7 +19835,6 @@
           <a:lstStyle/>
           <a:p>
             <a:pPr algn="ctr"/>
-            <a:endParaRPr/>
           </a:p>
         </p:txBody>
       </p:sp>
@@ -20407,7 +20165,6 @@
           <a:lstStyle/>
           <a:p>
             <a:pPr algn="ctr"/>
-            <a:endParaRPr/>
           </a:p>
         </p:txBody>
       </p:sp>

</xml_diff>